<commit_message>
Actualiser le rapport et le PDF
</commit_message>
<xml_diff>
--- a/reports/rapport.pptx
+++ b/reports/rapport.pptx
@@ -14,6 +14,7 @@
     <p:sldId id="262" r:id="rId13"/>
     <p:sldId id="263" r:id="rId14"/>
     <p:sldId id="264" r:id="rId15"/>
+    <p:sldId id="265" r:id="rId16"/>
   </p:sldIdLst>
   <p:sldSz cx="12191695" cy="6858000" type="screen4x3"/>
   <p:notesSz cx="6858000" cy="9144000"/>
@@ -3689,6 +3690,1363 @@
 </p:sld>
 </file>
 
+<file path=ppt/slides/slide10.xml><?xml version="1.0" encoding="utf-8"?>
+<p:sld xmlns:a="http://schemas.openxmlformats.org/drawingml/2006/main" xmlns:p="http://schemas.openxmlformats.org/presentationml/2006/main" xmlns:r="http://schemas.openxmlformats.org/officeDocument/2006/relationships">
+  <p:cSld>
+    <p:spTree>
+      <p:nvGrpSpPr>
+        <p:cNvPr id="1" name=""/>
+        <p:cNvGrpSpPr/>
+        <p:nvPr/>
+      </p:nvGrpSpPr>
+      <p:grpSpPr/>
+      <p:sp>
+        <p:nvSpPr>
+          <p:cNvPr id="2" name="Rectangle 1"/>
+          <p:cNvSpPr/>
+          <p:nvPr/>
+        </p:nvSpPr>
+        <p:spPr>
+          <a:xfrm>
+            <a:off x="0" y="0"/>
+            <a:ext cx="12191695" cy="1051560"/>
+          </a:xfrm>
+          <a:prstGeom prst="rect">
+            <a:avLst/>
+          </a:prstGeom>
+          <a:solidFill>
+            <a:srgbClr val="0B4F4A"/>
+          </a:solidFill>
+          <a:ln>
+            <a:noFill/>
+          </a:ln>
+          <a:effectLst/>
+        </p:spPr>
+        <p:style>
+          <a:lnRef idx="1">
+            <a:schemeClr val="accent1"/>
+          </a:lnRef>
+          <a:fillRef idx="3">
+            <a:schemeClr val="accent1"/>
+          </a:fillRef>
+          <a:fontRef idx="minor">
+            <a:schemeClr val="lt1"/>
+          </a:fontRef>
+        </p:style>
+        <p:txBody>
+          <a:bodyPr rtlCol="0" anchor="ctr"/>
+          <a:lstStyle/>
+          <a:p>
+            <a:pPr algn="ctr"/>
+          </a:p>
+        </p:txBody>
+      </p:sp>
+      <p:sp>
+        <p:nvSpPr>
+          <p:cNvPr id="3" name="Rectangle 2"/>
+          <p:cNvSpPr/>
+          <p:nvPr/>
+        </p:nvSpPr>
+        <p:spPr>
+          <a:xfrm>
+            <a:off x="0" y="1051560"/>
+            <a:ext cx="12191695" cy="50800"/>
+          </a:xfrm>
+          <a:prstGeom prst="rect">
+            <a:avLst/>
+          </a:prstGeom>
+          <a:solidFill>
+            <a:srgbClr val="F4B400"/>
+          </a:solidFill>
+          <a:ln>
+            <a:noFill/>
+          </a:ln>
+          <a:effectLst/>
+        </p:spPr>
+        <p:style>
+          <a:lnRef idx="1">
+            <a:schemeClr val="accent1"/>
+          </a:lnRef>
+          <a:fillRef idx="3">
+            <a:schemeClr val="accent1"/>
+          </a:fillRef>
+          <a:fontRef idx="minor">
+            <a:schemeClr val="lt1"/>
+          </a:fontRef>
+        </p:style>
+        <p:txBody>
+          <a:bodyPr rtlCol="0" anchor="ctr"/>
+          <a:lstStyle/>
+          <a:p>
+            <a:pPr algn="ctr"/>
+          </a:p>
+        </p:txBody>
+      </p:sp>
+      <p:pic>
+        <p:nvPicPr>
+          <p:cNvPr id="4" name="Picture 3" descr="logo-datalab.png"/>
+          <p:cNvPicPr>
+            <a:picLocks noChangeAspect="1"/>
+          </p:cNvPicPr>
+          <p:nvPr/>
+        </p:nvPicPr>
+        <p:blipFill>
+          <a:blip r:embed="rId2"/>
+          <a:stretch>
+            <a:fillRect/>
+          </a:stretch>
+        </p:blipFill>
+        <p:spPr>
+          <a:xfrm>
+            <a:off x="11475720" y="164592"/>
+            <a:ext cx="292608" cy="457200"/>
+          </a:xfrm>
+          <a:prstGeom prst="rect">
+            <a:avLst/>
+          </a:prstGeom>
+        </p:spPr>
+      </p:pic>
+      <p:sp>
+        <p:nvSpPr>
+          <p:cNvPr id="5" name="TextBox 4"/>
+          <p:cNvSpPr txBox="1"/>
+          <p:nvPr/>
+        </p:nvSpPr>
+        <p:spPr>
+          <a:xfrm>
+            <a:off x="457200" y="109728"/>
+            <a:ext cx="10789920" cy="256032"/>
+          </a:xfrm>
+          <a:prstGeom prst="rect">
+            <a:avLst/>
+          </a:prstGeom>
+          <a:noFill/>
+        </p:spPr>
+        <p:txBody>
+          <a:bodyPr wrap="square" anchor="t" lIns="50800" rIns="50800" tIns="50800" bIns="50800">
+            <a:spAutoFit/>
+          </a:bodyPr>
+          <a:lstStyle/>
+          <a:p>
+            <a:pPr algn="l"/>
+            <a:r>
+              <a:rPr sz="1000" b="1">
+                <a:solidFill>
+                  <a:srgbClr val="F4B400"/>
+                </a:solidFill>
+                <a:latin typeface="Poppins"/>
+              </a:rPr>
+              <a:t>CONCLUSION</a:t>
+            </a:r>
+          </a:p>
+        </p:txBody>
+      </p:sp>
+      <p:sp>
+        <p:nvSpPr>
+          <p:cNvPr id="6" name="TextBox 5"/>
+          <p:cNvSpPr txBox="1"/>
+          <p:nvPr/>
+        </p:nvSpPr>
+        <p:spPr>
+          <a:xfrm>
+            <a:off x="457200" y="347472"/>
+            <a:ext cx="10789920" cy="640080"/>
+          </a:xfrm>
+          <a:prstGeom prst="rect">
+            <a:avLst/>
+          </a:prstGeom>
+          <a:noFill/>
+        </p:spPr>
+        <p:txBody>
+          <a:bodyPr wrap="square" anchor="t" lIns="50800" rIns="50800" tIns="50800" bIns="50800">
+            <a:spAutoFit/>
+          </a:bodyPr>
+          <a:lstStyle/>
+          <a:p>
+            <a:pPr algn="l"/>
+            <a:r>
+              <a:rPr sz="2200" b="1">
+                <a:solidFill>
+                  <a:srgbClr val="FFFFFF"/>
+                </a:solidFill>
+                <a:latin typeface="Poppins"/>
+              </a:rPr>
+              <a:t>Conclusion &amp; Feuille de Route Gouvernance</a:t>
+            </a:r>
+          </a:p>
+        </p:txBody>
+      </p:sp>
+      <p:sp>
+        <p:nvSpPr>
+          <p:cNvPr id="7" name="Rectangle 6"/>
+          <p:cNvSpPr/>
+          <p:nvPr/>
+        </p:nvSpPr>
+        <p:spPr>
+          <a:xfrm>
+            <a:off x="457200" y="1280160"/>
+            <a:ext cx="5486400" cy="4937760"/>
+          </a:xfrm>
+          <a:prstGeom prst="rect">
+            <a:avLst/>
+          </a:prstGeom>
+          <a:solidFill>
+            <a:srgbClr val="FFFFFF"/>
+          </a:solidFill>
+          <a:ln w="7620">
+            <a:solidFill>
+              <a:srgbClr val="D8E3E1"/>
+            </a:solidFill>
+          </a:ln>
+          <a:effectLst/>
+        </p:spPr>
+        <p:style>
+          <a:lnRef idx="1">
+            <a:schemeClr val="accent1"/>
+          </a:lnRef>
+          <a:fillRef idx="3">
+            <a:schemeClr val="accent1"/>
+          </a:fillRef>
+          <a:fontRef idx="minor">
+            <a:schemeClr val="lt1"/>
+          </a:fontRef>
+        </p:style>
+        <p:txBody>
+          <a:bodyPr rtlCol="0" anchor="ctr"/>
+          <a:lstStyle/>
+          <a:p>
+            <a:pPr algn="ctr"/>
+          </a:p>
+        </p:txBody>
+      </p:sp>
+      <p:sp>
+        <p:nvSpPr>
+          <p:cNvPr id="8" name="TextBox 7"/>
+          <p:cNvSpPr txBox="1"/>
+          <p:nvPr/>
+        </p:nvSpPr>
+        <p:spPr>
+          <a:xfrm>
+            <a:off x="640080" y="1463040"/>
+            <a:ext cx="5120640" cy="365760"/>
+          </a:xfrm>
+          <a:prstGeom prst="rect">
+            <a:avLst/>
+          </a:prstGeom>
+          <a:noFill/>
+        </p:spPr>
+        <p:txBody>
+          <a:bodyPr wrap="square" anchor="t" lIns="50800" rIns="50800" tIns="50800" bIns="50800">
+            <a:spAutoFit/>
+          </a:bodyPr>
+          <a:lstStyle/>
+          <a:p>
+            <a:pPr algn="l"/>
+            <a:r>
+              <a:rPr sz="1500" b="1">
+                <a:solidFill>
+                  <a:srgbClr val="0B4F4A"/>
+                </a:solidFill>
+                <a:latin typeface="Poppins"/>
+              </a:rPr>
+              <a:t>Bilan Synthétique du Diagnostic</a:t>
+            </a:r>
+          </a:p>
+        </p:txBody>
+      </p:sp>
+      <p:sp>
+        <p:nvSpPr>
+          <p:cNvPr id="9" name="Rectangle 8"/>
+          <p:cNvSpPr/>
+          <p:nvPr/>
+        </p:nvSpPr>
+        <p:spPr>
+          <a:xfrm>
+            <a:off x="640080" y="1965960"/>
+            <a:ext cx="50800" cy="777240"/>
+          </a:xfrm>
+          <a:prstGeom prst="rect">
+            <a:avLst/>
+          </a:prstGeom>
+          <a:solidFill>
+            <a:srgbClr val="0B4F4A"/>
+          </a:solidFill>
+          <a:ln>
+            <a:noFill/>
+          </a:ln>
+          <a:effectLst/>
+        </p:spPr>
+        <p:style>
+          <a:lnRef idx="1">
+            <a:schemeClr val="accent1"/>
+          </a:lnRef>
+          <a:fillRef idx="3">
+            <a:schemeClr val="accent1"/>
+          </a:fillRef>
+          <a:fontRef idx="minor">
+            <a:schemeClr val="lt1"/>
+          </a:fontRef>
+        </p:style>
+        <p:txBody>
+          <a:bodyPr rtlCol="0" anchor="ctr"/>
+          <a:lstStyle/>
+          <a:p>
+            <a:pPr algn="ctr"/>
+          </a:p>
+        </p:txBody>
+      </p:sp>
+      <p:sp>
+        <p:nvSpPr>
+          <p:cNvPr id="10" name="TextBox 9"/>
+          <p:cNvSpPr txBox="1"/>
+          <p:nvPr/>
+        </p:nvSpPr>
+        <p:spPr>
+          <a:xfrm>
+            <a:off x="777240" y="1965960"/>
+            <a:ext cx="4937760" cy="274320"/>
+          </a:xfrm>
+          <a:prstGeom prst="rect">
+            <a:avLst/>
+          </a:prstGeom>
+          <a:noFill/>
+        </p:spPr>
+        <p:txBody>
+          <a:bodyPr wrap="square" anchor="t" lIns="50800" rIns="50800" tIns="50800" bIns="50800">
+            <a:spAutoFit/>
+          </a:bodyPr>
+          <a:lstStyle/>
+          <a:p>
+            <a:pPr algn="l"/>
+            <a:r>
+              <a:rPr sz="1200" b="1">
+                <a:solidFill>
+                  <a:srgbClr val="0B4F4A"/>
+                </a:solidFill>
+                <a:latin typeface="Poppins"/>
+              </a:rPr>
+              <a:t>Couverture Hétérogène</a:t>
+            </a:r>
+          </a:p>
+        </p:txBody>
+      </p:sp>
+      <p:sp>
+        <p:nvSpPr>
+          <p:cNvPr id="11" name="TextBox 10"/>
+          <p:cNvSpPr txBox="1"/>
+          <p:nvPr/>
+        </p:nvSpPr>
+        <p:spPr>
+          <a:xfrm>
+            <a:off x="777240" y="2221992"/>
+            <a:ext cx="4937760" cy="548640"/>
+          </a:xfrm>
+          <a:prstGeom prst="rect">
+            <a:avLst/>
+          </a:prstGeom>
+          <a:noFill/>
+        </p:spPr>
+        <p:txBody>
+          <a:bodyPr wrap="square" anchor="t" lIns="50800" rIns="50800" tIns="50800" bIns="50800">
+            <a:spAutoFit/>
+          </a:bodyPr>
+          <a:lstStyle/>
+          <a:p>
+            <a:pPr algn="l"/>
+            <a:r>
+              <a:rPr sz="1100" b="0">
+                <a:solidFill>
+                  <a:srgbClr val="16302C"/>
+                </a:solidFill>
+                <a:latin typeface="Poppins"/>
+              </a:rPr>
+              <a:t>Forte disparité spatiale entre la région Maritime (TdE) et le corridor Nord (COSO).</a:t>
+            </a:r>
+          </a:p>
+        </p:txBody>
+      </p:sp>
+      <p:sp>
+        <p:nvSpPr>
+          <p:cNvPr id="12" name="Rectangle 11"/>
+          <p:cNvSpPr/>
+          <p:nvPr/>
+        </p:nvSpPr>
+        <p:spPr>
+          <a:xfrm>
+            <a:off x="640080" y="3017520"/>
+            <a:ext cx="50800" cy="777240"/>
+          </a:xfrm>
+          <a:prstGeom prst="rect">
+            <a:avLst/>
+          </a:prstGeom>
+          <a:solidFill>
+            <a:srgbClr val="0B4F4A"/>
+          </a:solidFill>
+          <a:ln>
+            <a:noFill/>
+          </a:ln>
+          <a:effectLst/>
+        </p:spPr>
+        <p:style>
+          <a:lnRef idx="1">
+            <a:schemeClr val="accent1"/>
+          </a:lnRef>
+          <a:fillRef idx="3">
+            <a:schemeClr val="accent1"/>
+          </a:fillRef>
+          <a:fontRef idx="minor">
+            <a:schemeClr val="lt1"/>
+          </a:fontRef>
+        </p:style>
+        <p:txBody>
+          <a:bodyPr rtlCol="0" anchor="ctr"/>
+          <a:lstStyle/>
+          <a:p>
+            <a:pPr algn="ctr"/>
+          </a:p>
+        </p:txBody>
+      </p:sp>
+      <p:sp>
+        <p:nvSpPr>
+          <p:cNvPr id="13" name="TextBox 12"/>
+          <p:cNvSpPr txBox="1"/>
+          <p:nvPr/>
+        </p:nvSpPr>
+        <p:spPr>
+          <a:xfrm>
+            <a:off x="777240" y="3017520"/>
+            <a:ext cx="4937760" cy="274320"/>
+          </a:xfrm>
+          <a:prstGeom prst="rect">
+            <a:avLst/>
+          </a:prstGeom>
+          <a:noFill/>
+        </p:spPr>
+        <p:txBody>
+          <a:bodyPr wrap="square" anchor="t" lIns="50800" rIns="50800" tIns="50800" bIns="50800">
+            <a:spAutoFit/>
+          </a:bodyPr>
+          <a:lstStyle/>
+          <a:p>
+            <a:pPr algn="l"/>
+            <a:r>
+              <a:rPr sz="1200" b="1">
+                <a:solidFill>
+                  <a:srgbClr val="0B4F4A"/>
+                </a:solidFill>
+                <a:latin typeface="Poppins"/>
+              </a:rPr>
+              <a:t>Durabilité à Sécuriser</a:t>
+            </a:r>
+          </a:p>
+        </p:txBody>
+      </p:sp>
+      <p:sp>
+        <p:nvSpPr>
+          <p:cNvPr id="14" name="TextBox 13"/>
+          <p:cNvSpPr txBox="1"/>
+          <p:nvPr/>
+        </p:nvSpPr>
+        <p:spPr>
+          <a:xfrm>
+            <a:off x="777240" y="3273552"/>
+            <a:ext cx="4937760" cy="548640"/>
+          </a:xfrm>
+          <a:prstGeom prst="rect">
+            <a:avLst/>
+          </a:prstGeom>
+          <a:noFill/>
+        </p:spPr>
+        <p:txBody>
+          <a:bodyPr wrap="square" anchor="t" lIns="50800" rIns="50800" tIns="50800" bIns="50800">
+            <a:spAutoFit/>
+          </a:bodyPr>
+          <a:lstStyle/>
+          <a:p>
+            <a:pPr algn="l"/>
+            <a:r>
+              <a:rPr sz="1100" b="0">
+                <a:solidFill>
+                  <a:srgbClr val="16302C"/>
+                </a:solidFill>
+                <a:latin typeface="Poppins"/>
+              </a:rPr>
+              <a:t>Seuls 20.6 % des ouvrages COSO ont un plan d'entretien documenté, nécessitant un suivi rigoureux.</a:t>
+            </a:r>
+          </a:p>
+        </p:txBody>
+      </p:sp>
+      <p:sp>
+        <p:nvSpPr>
+          <p:cNvPr id="15" name="Rectangle 14"/>
+          <p:cNvSpPr/>
+          <p:nvPr/>
+        </p:nvSpPr>
+        <p:spPr>
+          <a:xfrm>
+            <a:off x="640080" y="4069080"/>
+            <a:ext cx="50800" cy="777240"/>
+          </a:xfrm>
+          <a:prstGeom prst="rect">
+            <a:avLst/>
+          </a:prstGeom>
+          <a:solidFill>
+            <a:srgbClr val="0B4F4A"/>
+          </a:solidFill>
+          <a:ln>
+            <a:noFill/>
+          </a:ln>
+          <a:effectLst/>
+        </p:spPr>
+        <p:style>
+          <a:lnRef idx="1">
+            <a:schemeClr val="accent1"/>
+          </a:lnRef>
+          <a:fillRef idx="3">
+            <a:schemeClr val="accent1"/>
+          </a:fillRef>
+          <a:fontRef idx="minor">
+            <a:schemeClr val="lt1"/>
+          </a:fontRef>
+        </p:style>
+        <p:txBody>
+          <a:bodyPr rtlCol="0" anchor="ctr"/>
+          <a:lstStyle/>
+          <a:p>
+            <a:pPr algn="ctr"/>
+          </a:p>
+        </p:txBody>
+      </p:sp>
+      <p:sp>
+        <p:nvSpPr>
+          <p:cNvPr id="16" name="TextBox 15"/>
+          <p:cNvSpPr txBox="1"/>
+          <p:nvPr/>
+        </p:nvSpPr>
+        <p:spPr>
+          <a:xfrm>
+            <a:off x="777240" y="4069080"/>
+            <a:ext cx="4937760" cy="274320"/>
+          </a:xfrm>
+          <a:prstGeom prst="rect">
+            <a:avLst/>
+          </a:prstGeom>
+          <a:noFill/>
+        </p:spPr>
+        <p:txBody>
+          <a:bodyPr wrap="square" anchor="t" lIns="50800" rIns="50800" tIns="50800" bIns="50800">
+            <a:spAutoFit/>
+          </a:bodyPr>
+          <a:lstStyle/>
+          <a:p>
+            <a:pPr algn="l"/>
+            <a:r>
+              <a:rPr sz="1200" b="1">
+                <a:solidFill>
+                  <a:srgbClr val="0B4F4A"/>
+                </a:solidFill>
+                <a:latin typeface="Poppins"/>
+              </a:rPr>
+              <a:t>Vulnérabilité Climatique</a:t>
+            </a:r>
+          </a:p>
+        </p:txBody>
+      </p:sp>
+      <p:sp>
+        <p:nvSpPr>
+          <p:cNvPr id="17" name="TextBox 16"/>
+          <p:cNvSpPr txBox="1"/>
+          <p:nvPr/>
+        </p:nvSpPr>
+        <p:spPr>
+          <a:xfrm>
+            <a:off x="777240" y="4325112"/>
+            <a:ext cx="4937760" cy="548640"/>
+          </a:xfrm>
+          <a:prstGeom prst="rect">
+            <a:avLst/>
+          </a:prstGeom>
+          <a:noFill/>
+        </p:spPr>
+        <p:txBody>
+          <a:bodyPr wrap="square" anchor="t" lIns="50800" rIns="50800" tIns="50800" bIns="50800">
+            <a:spAutoFit/>
+          </a:bodyPr>
+          <a:lstStyle/>
+          <a:p>
+            <a:pPr algn="l"/>
+            <a:r>
+              <a:rPr sz="1100" b="0">
+                <a:solidFill>
+                  <a:srgbClr val="16302C"/>
+                </a:solidFill>
+                <a:latin typeface="Poppins"/>
+              </a:rPr>
+              <a:t>77 ouvrages géolocalisés sont exposés à un risque d'inondation élevé (FRI &gt; 0.13).</a:t>
+            </a:r>
+          </a:p>
+        </p:txBody>
+      </p:sp>
+      <p:sp>
+        <p:nvSpPr>
+          <p:cNvPr id="18" name="Rectangle 17"/>
+          <p:cNvSpPr/>
+          <p:nvPr/>
+        </p:nvSpPr>
+        <p:spPr>
+          <a:xfrm>
+            <a:off x="640080" y="5120640"/>
+            <a:ext cx="50800" cy="777240"/>
+          </a:xfrm>
+          <a:prstGeom prst="rect">
+            <a:avLst/>
+          </a:prstGeom>
+          <a:solidFill>
+            <a:srgbClr val="0B4F4A"/>
+          </a:solidFill>
+          <a:ln>
+            <a:noFill/>
+          </a:ln>
+          <a:effectLst/>
+        </p:spPr>
+        <p:style>
+          <a:lnRef idx="1">
+            <a:schemeClr val="accent1"/>
+          </a:lnRef>
+          <a:fillRef idx="3">
+            <a:schemeClr val="accent1"/>
+          </a:fillRef>
+          <a:fontRef idx="minor">
+            <a:schemeClr val="lt1"/>
+          </a:fontRef>
+        </p:style>
+        <p:txBody>
+          <a:bodyPr rtlCol="0" anchor="ctr"/>
+          <a:lstStyle/>
+          <a:p>
+            <a:pPr algn="ctr"/>
+          </a:p>
+        </p:txBody>
+      </p:sp>
+      <p:sp>
+        <p:nvSpPr>
+          <p:cNvPr id="19" name="TextBox 18"/>
+          <p:cNvSpPr txBox="1"/>
+          <p:nvPr/>
+        </p:nvSpPr>
+        <p:spPr>
+          <a:xfrm>
+            <a:off x="777240" y="5120640"/>
+            <a:ext cx="4937760" cy="274320"/>
+          </a:xfrm>
+          <a:prstGeom prst="rect">
+            <a:avLst/>
+          </a:prstGeom>
+          <a:noFill/>
+        </p:spPr>
+        <p:txBody>
+          <a:bodyPr wrap="square" anchor="t" lIns="50800" rIns="50800" tIns="50800" bIns="50800">
+            <a:spAutoFit/>
+          </a:bodyPr>
+          <a:lstStyle/>
+          <a:p>
+            <a:pPr algn="l"/>
+            <a:r>
+              <a:rPr sz="1200" b="1">
+                <a:solidFill>
+                  <a:srgbClr val="0B4F4A"/>
+                </a:solidFill>
+                <a:latin typeface="Poppins"/>
+              </a:rPr>
+              <a:t>Livrables Opérationnels</a:t>
+            </a:r>
+          </a:p>
+        </p:txBody>
+      </p:sp>
+      <p:sp>
+        <p:nvSpPr>
+          <p:cNvPr id="20" name="TextBox 19"/>
+          <p:cNvSpPr txBox="1"/>
+          <p:nvPr/>
+        </p:nvSpPr>
+        <p:spPr>
+          <a:xfrm>
+            <a:off x="777240" y="5376672"/>
+            <a:ext cx="4937760" cy="548640"/>
+          </a:xfrm>
+          <a:prstGeom prst="rect">
+            <a:avLst/>
+          </a:prstGeom>
+          <a:noFill/>
+        </p:spPr>
+        <p:txBody>
+          <a:bodyPr wrap="square" anchor="t" lIns="50800" rIns="50800" tIns="50800" bIns="50800">
+            <a:spAutoFit/>
+          </a:bodyPr>
+          <a:lstStyle/>
+          <a:p>
+            <a:pPr algn="l"/>
+            <a:r>
+              <a:rPr sz="1100" b="0">
+                <a:solidFill>
+                  <a:srgbClr val="16302C"/>
+                </a:solidFill>
+                <a:latin typeface="Poppins"/>
+              </a:rPr>
+              <a:t>Un dashboard interactif, son archive de soumission et ce rapport d'analyse pour guider les décideurs.</a:t>
+            </a:r>
+          </a:p>
+        </p:txBody>
+      </p:sp>
+      <p:sp>
+        <p:nvSpPr>
+          <p:cNvPr id="21" name="Rectangle 20"/>
+          <p:cNvSpPr/>
+          <p:nvPr/>
+        </p:nvSpPr>
+        <p:spPr>
+          <a:xfrm>
+            <a:off x="6217920" y="1280160"/>
+            <a:ext cx="5486400" cy="4937760"/>
+          </a:xfrm>
+          <a:prstGeom prst="rect">
+            <a:avLst/>
+          </a:prstGeom>
+          <a:solidFill>
+            <a:srgbClr val="F4F7F6"/>
+          </a:solidFill>
+          <a:ln w="7620">
+            <a:solidFill>
+              <a:srgbClr val="D8E3E1"/>
+            </a:solidFill>
+          </a:ln>
+          <a:effectLst/>
+        </p:spPr>
+        <p:style>
+          <a:lnRef idx="1">
+            <a:schemeClr val="accent1"/>
+          </a:lnRef>
+          <a:fillRef idx="3">
+            <a:schemeClr val="accent1"/>
+          </a:fillRef>
+          <a:fontRef idx="minor">
+            <a:schemeClr val="lt1"/>
+          </a:fontRef>
+        </p:style>
+        <p:txBody>
+          <a:bodyPr rtlCol="0" anchor="ctr"/>
+          <a:lstStyle/>
+          <a:p>
+            <a:pPr algn="ctr"/>
+          </a:p>
+        </p:txBody>
+      </p:sp>
+      <p:sp>
+        <p:nvSpPr>
+          <p:cNvPr id="22" name="TextBox 21"/>
+          <p:cNvSpPr txBox="1"/>
+          <p:nvPr/>
+        </p:nvSpPr>
+        <p:spPr>
+          <a:xfrm>
+            <a:off x="6400800" y="1463040"/>
+            <a:ext cx="5120640" cy="365760"/>
+          </a:xfrm>
+          <a:prstGeom prst="rect">
+            <a:avLst/>
+          </a:prstGeom>
+          <a:noFill/>
+        </p:spPr>
+        <p:txBody>
+          <a:bodyPr wrap="square" anchor="t" lIns="50800" rIns="50800" tIns="50800" bIns="50800">
+            <a:spAutoFit/>
+          </a:bodyPr>
+          <a:lstStyle/>
+          <a:p>
+            <a:pPr algn="l"/>
+            <a:r>
+              <a:rPr sz="1500" b="1">
+                <a:solidFill>
+                  <a:srgbClr val="0B4F4A"/>
+                </a:solidFill>
+                <a:latin typeface="Poppins"/>
+              </a:rPr>
+              <a:t>Feuille de Route pour la Gouvernance</a:t>
+            </a:r>
+          </a:p>
+        </p:txBody>
+      </p:sp>
+      <p:sp>
+        <p:nvSpPr>
+          <p:cNvPr id="23" name="Rectangle 22"/>
+          <p:cNvSpPr/>
+          <p:nvPr/>
+        </p:nvSpPr>
+        <p:spPr>
+          <a:xfrm>
+            <a:off x="6400800" y="1965960"/>
+            <a:ext cx="5120640" cy="822960"/>
+          </a:xfrm>
+          <a:prstGeom prst="rect">
+            <a:avLst/>
+          </a:prstGeom>
+          <a:solidFill>
+            <a:srgbClr val="FFFFFF"/>
+          </a:solidFill>
+          <a:ln w="7620">
+            <a:solidFill>
+              <a:srgbClr val="E0EBE8"/>
+            </a:solidFill>
+          </a:ln>
+          <a:effectLst/>
+        </p:spPr>
+        <p:style>
+          <a:lnRef idx="1">
+            <a:schemeClr val="accent1"/>
+          </a:lnRef>
+          <a:fillRef idx="3">
+            <a:schemeClr val="accent1"/>
+          </a:fillRef>
+          <a:fontRef idx="minor">
+            <a:schemeClr val="lt1"/>
+          </a:fontRef>
+        </p:style>
+        <p:txBody>
+          <a:bodyPr rtlCol="0" anchor="ctr"/>
+          <a:lstStyle/>
+          <a:p>
+            <a:pPr algn="ctr"/>
+          </a:p>
+        </p:txBody>
+      </p:sp>
+      <p:sp>
+        <p:nvSpPr>
+          <p:cNvPr id="24" name="TextBox 23"/>
+          <p:cNvSpPr txBox="1"/>
+          <p:nvPr/>
+        </p:nvSpPr>
+        <p:spPr>
+          <a:xfrm>
+            <a:off x="6583680" y="2075688"/>
+            <a:ext cx="4754880" cy="274320"/>
+          </a:xfrm>
+          <a:prstGeom prst="rect">
+            <a:avLst/>
+          </a:prstGeom>
+          <a:noFill/>
+        </p:spPr>
+        <p:txBody>
+          <a:bodyPr wrap="square" anchor="t" lIns="50800" rIns="50800" tIns="50800" bIns="50800">
+            <a:spAutoFit/>
+          </a:bodyPr>
+          <a:lstStyle/>
+          <a:p>
+            <a:pPr algn="l"/>
+            <a:r>
+              <a:rPr sz="1200" b="1">
+                <a:solidFill>
+                  <a:srgbClr val="14877D"/>
+                </a:solidFill>
+                <a:latin typeface="Poppins"/>
+              </a:rPr>
+              <a:t>Étape 1 : Standardisation</a:t>
+            </a:r>
+          </a:p>
+        </p:txBody>
+      </p:sp>
+      <p:sp>
+        <p:nvSpPr>
+          <p:cNvPr id="25" name="TextBox 24"/>
+          <p:cNvSpPr txBox="1"/>
+          <p:nvPr/>
+        </p:nvSpPr>
+        <p:spPr>
+          <a:xfrm>
+            <a:off x="6583680" y="2331720"/>
+            <a:ext cx="4754880" cy="411480"/>
+          </a:xfrm>
+          <a:prstGeom prst="rect">
+            <a:avLst/>
+          </a:prstGeom>
+          <a:noFill/>
+        </p:spPr>
+        <p:txBody>
+          <a:bodyPr wrap="square" anchor="t" lIns="50800" rIns="50800" tIns="50800" bIns="50800">
+            <a:spAutoFit/>
+          </a:bodyPr>
+          <a:lstStyle/>
+          <a:p>
+            <a:pPr algn="l"/>
+            <a:r>
+              <a:rPr sz="1100" b="0">
+                <a:solidFill>
+                  <a:srgbClr val="16302C"/>
+                </a:solidFill>
+                <a:latin typeface="Poppins"/>
+              </a:rPr>
+              <a:t>Instaurer un schéma géographique commun (GPS, codes cantons) pour tous les projets d'eau.</a:t>
+            </a:r>
+          </a:p>
+        </p:txBody>
+      </p:sp>
+      <p:sp>
+        <p:nvSpPr>
+          <p:cNvPr id="26" name="Rectangle 25"/>
+          <p:cNvSpPr/>
+          <p:nvPr/>
+        </p:nvSpPr>
+        <p:spPr>
+          <a:xfrm>
+            <a:off x="6400800" y="3017520"/>
+            <a:ext cx="5120640" cy="822960"/>
+          </a:xfrm>
+          <a:prstGeom prst="rect">
+            <a:avLst/>
+          </a:prstGeom>
+          <a:solidFill>
+            <a:srgbClr val="FFFFFF"/>
+          </a:solidFill>
+          <a:ln w="7620">
+            <a:solidFill>
+              <a:srgbClr val="E0EBE8"/>
+            </a:solidFill>
+          </a:ln>
+          <a:effectLst/>
+        </p:spPr>
+        <p:style>
+          <a:lnRef idx="1">
+            <a:schemeClr val="accent1"/>
+          </a:lnRef>
+          <a:fillRef idx="3">
+            <a:schemeClr val="accent1"/>
+          </a:fillRef>
+          <a:fontRef idx="minor">
+            <a:schemeClr val="lt1"/>
+          </a:fontRef>
+        </p:style>
+        <p:txBody>
+          <a:bodyPr rtlCol="0" anchor="ctr"/>
+          <a:lstStyle/>
+          <a:p>
+            <a:pPr algn="ctr"/>
+          </a:p>
+        </p:txBody>
+      </p:sp>
+      <p:sp>
+        <p:nvSpPr>
+          <p:cNvPr id="27" name="TextBox 26"/>
+          <p:cNvSpPr txBox="1"/>
+          <p:nvPr/>
+        </p:nvSpPr>
+        <p:spPr>
+          <a:xfrm>
+            <a:off x="6583680" y="3127248"/>
+            <a:ext cx="4754880" cy="274320"/>
+          </a:xfrm>
+          <a:prstGeom prst="rect">
+            <a:avLst/>
+          </a:prstGeom>
+          <a:noFill/>
+        </p:spPr>
+        <p:txBody>
+          <a:bodyPr wrap="square" anchor="t" lIns="50800" rIns="50800" tIns="50800" bIns="50800">
+            <a:spAutoFit/>
+          </a:bodyPr>
+          <a:lstStyle/>
+          <a:p>
+            <a:pPr algn="l"/>
+            <a:r>
+              <a:rPr sz="1200" b="1">
+                <a:solidFill>
+                  <a:srgbClr val="14877D"/>
+                </a:solidFill>
+                <a:latin typeface="Poppins"/>
+              </a:rPr>
+              <a:t>Étape 2 : Campagne Terrain</a:t>
+            </a:r>
+          </a:p>
+        </p:txBody>
+      </p:sp>
+      <p:sp>
+        <p:nvSpPr>
+          <p:cNvPr id="28" name="TextBox 27"/>
+          <p:cNvSpPr txBox="1"/>
+          <p:nvPr/>
+        </p:nvSpPr>
+        <p:spPr>
+          <a:xfrm>
+            <a:off x="6583680" y="3383280"/>
+            <a:ext cx="4754880" cy="411480"/>
+          </a:xfrm>
+          <a:prstGeom prst="rect">
+            <a:avLst/>
+          </a:prstGeom>
+          <a:noFill/>
+        </p:spPr>
+        <p:txBody>
+          <a:bodyPr wrap="square" anchor="t" lIns="50800" rIns="50800" tIns="50800" bIns="50800">
+            <a:spAutoFit/>
+          </a:bodyPr>
+          <a:lstStyle/>
+          <a:p>
+            <a:pPr algn="l"/>
+            <a:r>
+              <a:rPr sz="1100" b="0">
+                <a:solidFill>
+                  <a:srgbClr val="16302C"/>
+                </a:solidFill>
+                <a:latin typeface="Poppins"/>
+              </a:rPr>
+              <a:t>Déployer un contrôle physique sur les 115 projets identifiés en priorité de contrôle.</a:t>
+            </a:r>
+          </a:p>
+        </p:txBody>
+      </p:sp>
+      <p:sp>
+        <p:nvSpPr>
+          <p:cNvPr id="29" name="Rectangle 28"/>
+          <p:cNvSpPr/>
+          <p:nvPr/>
+        </p:nvSpPr>
+        <p:spPr>
+          <a:xfrm>
+            <a:off x="6400800" y="4069080"/>
+            <a:ext cx="5120640" cy="822960"/>
+          </a:xfrm>
+          <a:prstGeom prst="rect">
+            <a:avLst/>
+          </a:prstGeom>
+          <a:solidFill>
+            <a:srgbClr val="FFFFFF"/>
+          </a:solidFill>
+          <a:ln w="7620">
+            <a:solidFill>
+              <a:srgbClr val="E0EBE8"/>
+            </a:solidFill>
+          </a:ln>
+          <a:effectLst/>
+        </p:spPr>
+        <p:style>
+          <a:lnRef idx="1">
+            <a:schemeClr val="accent1"/>
+          </a:lnRef>
+          <a:fillRef idx="3">
+            <a:schemeClr val="accent1"/>
+          </a:fillRef>
+          <a:fontRef idx="minor">
+            <a:schemeClr val="lt1"/>
+          </a:fontRef>
+        </p:style>
+        <p:txBody>
+          <a:bodyPr rtlCol="0" anchor="ctr"/>
+          <a:lstStyle/>
+          <a:p>
+            <a:pPr algn="ctr"/>
+          </a:p>
+        </p:txBody>
+      </p:sp>
+      <p:sp>
+        <p:nvSpPr>
+          <p:cNvPr id="30" name="TextBox 29"/>
+          <p:cNvSpPr txBox="1"/>
+          <p:nvPr/>
+        </p:nvSpPr>
+        <p:spPr>
+          <a:xfrm>
+            <a:off x="6583680" y="4178808"/>
+            <a:ext cx="4754880" cy="274320"/>
+          </a:xfrm>
+          <a:prstGeom prst="rect">
+            <a:avLst/>
+          </a:prstGeom>
+          <a:noFill/>
+        </p:spPr>
+        <p:txBody>
+          <a:bodyPr wrap="square" anchor="t" lIns="50800" rIns="50800" tIns="50800" bIns="50800">
+            <a:spAutoFit/>
+          </a:bodyPr>
+          <a:lstStyle/>
+          <a:p>
+            <a:pPr algn="l"/>
+            <a:r>
+              <a:rPr sz="1200" b="1">
+                <a:solidFill>
+                  <a:srgbClr val="14877D"/>
+                </a:solidFill>
+                <a:latin typeface="Poppins"/>
+              </a:rPr>
+              <a:t>Étape 3 : Publication ouverte</a:t>
+            </a:r>
+          </a:p>
+        </p:txBody>
+      </p:sp>
+      <p:sp>
+        <p:nvSpPr>
+          <p:cNvPr id="31" name="TextBox 30"/>
+          <p:cNvSpPr txBox="1"/>
+          <p:nvPr/>
+        </p:nvSpPr>
+        <p:spPr>
+          <a:xfrm>
+            <a:off x="6583680" y="4434840"/>
+            <a:ext cx="4754880" cy="411480"/>
+          </a:xfrm>
+          <a:prstGeom prst="rect">
+            <a:avLst/>
+          </a:prstGeom>
+          <a:noFill/>
+        </p:spPr>
+        <p:txBody>
+          <a:bodyPr wrap="square" anchor="t" lIns="50800" rIns="50800" tIns="50800" bIns="50800">
+            <a:spAutoFit/>
+          </a:bodyPr>
+          <a:lstStyle/>
+          <a:p>
+            <a:pPr algn="l"/>
+            <a:r>
+              <a:rPr sz="1100" b="0">
+                <a:solidFill>
+                  <a:srgbClr val="16302C"/>
+                </a:solidFill>
+                <a:latin typeface="Poppins"/>
+              </a:rPr>
+              <a:t>Documenter les mises à jour et publier les statuts terrain dans l'écosystème opendata.gouv.tg.</a:t>
+            </a:r>
+          </a:p>
+        </p:txBody>
+      </p:sp>
+      <p:sp>
+        <p:nvSpPr>
+          <p:cNvPr id="32" name="Rectangle 31"/>
+          <p:cNvSpPr/>
+          <p:nvPr/>
+        </p:nvSpPr>
+        <p:spPr>
+          <a:xfrm>
+            <a:off x="6400800" y="5120640"/>
+            <a:ext cx="5120640" cy="822960"/>
+          </a:xfrm>
+          <a:prstGeom prst="rect">
+            <a:avLst/>
+          </a:prstGeom>
+          <a:solidFill>
+            <a:srgbClr val="FFFFFF"/>
+          </a:solidFill>
+          <a:ln w="7620">
+            <a:solidFill>
+              <a:srgbClr val="E0EBE8"/>
+            </a:solidFill>
+          </a:ln>
+          <a:effectLst/>
+        </p:spPr>
+        <p:style>
+          <a:lnRef idx="1">
+            <a:schemeClr val="accent1"/>
+          </a:lnRef>
+          <a:fillRef idx="3">
+            <a:schemeClr val="accent1"/>
+          </a:fillRef>
+          <a:fontRef idx="minor">
+            <a:schemeClr val="lt1"/>
+          </a:fontRef>
+        </p:style>
+        <p:txBody>
+          <a:bodyPr rtlCol="0" anchor="ctr"/>
+          <a:lstStyle/>
+          <a:p>
+            <a:pPr algn="ctr"/>
+          </a:p>
+        </p:txBody>
+      </p:sp>
+      <p:sp>
+        <p:nvSpPr>
+          <p:cNvPr id="33" name="TextBox 32"/>
+          <p:cNvSpPr txBox="1"/>
+          <p:nvPr/>
+        </p:nvSpPr>
+        <p:spPr>
+          <a:xfrm>
+            <a:off x="6583680" y="5230368"/>
+            <a:ext cx="4754880" cy="274320"/>
+          </a:xfrm>
+          <a:prstGeom prst="rect">
+            <a:avLst/>
+          </a:prstGeom>
+          <a:noFill/>
+        </p:spPr>
+        <p:txBody>
+          <a:bodyPr wrap="square" anchor="t" lIns="50800" rIns="50800" tIns="50800" bIns="50800">
+            <a:spAutoFit/>
+          </a:bodyPr>
+          <a:lstStyle/>
+          <a:p>
+            <a:pPr algn="l"/>
+            <a:r>
+              <a:rPr sz="1200" b="1">
+                <a:solidFill>
+                  <a:srgbClr val="14877D"/>
+                </a:solidFill>
+                <a:latin typeface="Poppins"/>
+              </a:rPr>
+              <a:t>Étape 4 : Suivi d'Impact</a:t>
+            </a:r>
+          </a:p>
+        </p:txBody>
+      </p:sp>
+      <p:sp>
+        <p:nvSpPr>
+          <p:cNvPr id="34" name="TextBox 33"/>
+          <p:cNvSpPr txBox="1"/>
+          <p:nvPr/>
+        </p:nvSpPr>
+        <p:spPr>
+          <a:xfrm>
+            <a:off x="6583680" y="5486400"/>
+            <a:ext cx="4754880" cy="411480"/>
+          </a:xfrm>
+          <a:prstGeom prst="rect">
+            <a:avLst/>
+          </a:prstGeom>
+          <a:noFill/>
+        </p:spPr>
+        <p:txBody>
+          <a:bodyPr wrap="square" anchor="t" lIns="50800" rIns="50800" tIns="50800" bIns="50800">
+            <a:spAutoFit/>
+          </a:bodyPr>
+          <a:lstStyle/>
+          <a:p>
+            <a:pPr algn="l"/>
+            <a:r>
+              <a:rPr sz="1100" b="0">
+                <a:solidFill>
+                  <a:srgbClr val="16302C"/>
+                </a:solidFill>
+                <a:latin typeface="Poppins"/>
+              </a:rPr>
+              <a:t>Mesurer le taux de desserte effectif et la fonctionnalité réelle au niveau canton.</a:t>
+            </a:r>
+          </a:p>
+        </p:txBody>
+      </p:sp>
+      <p:sp>
+        <p:nvSpPr>
+          <p:cNvPr id="35" name="Rectangle 34"/>
+          <p:cNvSpPr/>
+          <p:nvPr/>
+        </p:nvSpPr>
+        <p:spPr>
+          <a:xfrm>
+            <a:off x="457200" y="6400800"/>
+            <a:ext cx="11277295" cy="8890"/>
+          </a:xfrm>
+          <a:prstGeom prst="rect">
+            <a:avLst/>
+          </a:prstGeom>
+          <a:solidFill>
+            <a:srgbClr val="D8E3E1"/>
+          </a:solidFill>
+          <a:ln>
+            <a:noFill/>
+          </a:ln>
+          <a:effectLst/>
+        </p:spPr>
+        <p:style>
+          <a:lnRef idx="1">
+            <a:schemeClr val="accent1"/>
+          </a:lnRef>
+          <a:fillRef idx="3">
+            <a:schemeClr val="accent1"/>
+          </a:fillRef>
+          <a:fontRef idx="minor">
+            <a:schemeClr val="lt1"/>
+          </a:fontRef>
+        </p:style>
+        <p:txBody>
+          <a:bodyPr rtlCol="0" anchor="ctr"/>
+          <a:lstStyle/>
+          <a:p>
+            <a:pPr algn="ctr"/>
+          </a:p>
+        </p:txBody>
+      </p:sp>
+      <p:sp>
+        <p:nvSpPr>
+          <p:cNvPr id="36" name="TextBox 35"/>
+          <p:cNvSpPr txBox="1"/>
+          <p:nvPr/>
+        </p:nvSpPr>
+        <p:spPr>
+          <a:xfrm>
+            <a:off x="457200" y="6473952"/>
+            <a:ext cx="9144000" cy="292608"/>
+          </a:xfrm>
+          <a:prstGeom prst="rect">
+            <a:avLst/>
+          </a:prstGeom>
+          <a:noFill/>
+        </p:spPr>
+        <p:txBody>
+          <a:bodyPr wrap="square" anchor="t" lIns="50800" rIns="50800" tIns="50800" bIns="50800">
+            <a:spAutoFit/>
+          </a:bodyPr>
+          <a:lstStyle/>
+          <a:p>
+            <a:pPr algn="l"/>
+            <a:r>
+              <a:rPr sz="900" b="0">
+                <a:solidFill>
+                  <a:srgbClr val="5D726E"/>
+                </a:solidFill>
+                <a:latin typeface="Poppins"/>
+              </a:rPr>
+              <a:t>TOGO AI LAB · Data Challenge Environnement (Défi 01) | Données Ouvertes TdE · COSO · INSEED · ISRI-TG</a:t>
+            </a:r>
+          </a:p>
+        </p:txBody>
+      </p:sp>
+      <p:sp>
+        <p:nvSpPr>
+          <p:cNvPr id="37" name="TextBox 36"/>
+          <p:cNvSpPr txBox="1"/>
+          <p:nvPr/>
+        </p:nvSpPr>
+        <p:spPr>
+          <a:xfrm>
+            <a:off x="11277295" y="6473952"/>
+            <a:ext cx="457200" cy="292608"/>
+          </a:xfrm>
+          <a:prstGeom prst="rect">
+            <a:avLst/>
+          </a:prstGeom>
+          <a:noFill/>
+        </p:spPr>
+        <p:txBody>
+          <a:bodyPr wrap="square" anchor="t" lIns="50800" rIns="50800" tIns="50800" bIns="50800">
+            <a:spAutoFit/>
+          </a:bodyPr>
+          <a:lstStyle/>
+          <a:p>
+            <a:pPr algn="r"/>
+            <a:r>
+              <a:rPr sz="900" b="1">
+                <a:solidFill>
+                  <a:srgbClr val="5D726E"/>
+                </a:solidFill>
+                <a:latin typeface="Poppins"/>
+              </a:rPr>
+              <a:t>10</a:t>
+            </a:r>
+          </a:p>
+        </p:txBody>
+      </p:sp>
+    </p:spTree>
+  </p:cSld>
+  <p:clrMapOvr>
+    <a:masterClrMapping/>
+  </p:clrMapOvr>
+</p:sld>
+</file>
+
 <file path=ppt/slides/slide2.xml><?xml version="1.0" encoding="utf-8"?>
 <p:sld xmlns:a="http://schemas.openxmlformats.org/drawingml/2006/main" xmlns:p="http://schemas.openxmlformats.org/presentationml/2006/main" xmlns:r="http://schemas.openxmlformats.org/officeDocument/2006/relationships">
   <p:cSld>
@@ -6293,7 +7651,7 @@
                 </a:solidFill>
                 <a:latin typeface="Poppins"/>
               </a:rPr>
-              <a:t>Les données ouvertes TdE et COSO ne contiennent pas les champs 'fonctionnel', 'en panne' ou 'abandonné'. Le taux de fonctionnalité réel ne peut donc pas être calculé directement.</a:t>
+              <a:t>Les données ouvertes TdE et COSO ne contiennent pas les champs 'fonctionnel', 'en panne' ou 'abandonné'. Le taux de fonctionnalité réel ne peut donc pas être calculé.</a:t>
             </a:r>
           </a:p>
         </p:txBody>
@@ -6515,7 +7873,7 @@
                 </a:solidFill>
                 <a:latin typeface="Poppins"/>
               </a:rPr>
-              <a:t>Un score composite (0 à 100) a été modélisé : absence de plan (45%), statut non définitif (25%), absence de remise (15%) et FRI (15%). Il classe 115 ouvrages en 'Priorité de contrôle' pour cibler les audits terrain.</a:t>
+              <a:t>Un score composite (0 à 100) a été modélisé : absence de plan (45%), statut non définitif (25%), absence de remise (15%) et FRI (15%). Il classe 115 projets en 'Priorité de contrôle' pour cibler les audits terrain.</a:t>
             </a:r>
           </a:p>
         </p:txBody>
@@ -7888,7 +9246,7 @@
                 </a:solidFill>
                 <a:latin typeface="Poppins"/>
               </a:rPr>
-              <a:t>Géolocalisés situés directement dans des cantons FRI 'Élevé' (47 en Maritime, 27 en Savanes).</a:t>
+              <a:t>Géolocalisés situés directement dans des cantons FRI 'Élevé'.</a:t>
             </a:r>
           </a:p>
         </p:txBody>
@@ -10947,7 +12305,7 @@
                 </a:solidFill>
                 <a:latin typeface="Poppins"/>
               </a:rPr>
-              <a:t>CONCLUSION</a:t>
+              <a:t>PLATEFORME</a:t>
             </a:r>
           </a:p>
         </p:txBody>
@@ -10982,7 +12340,7 @@
                 </a:solidFill>
                 <a:latin typeface="Poppins"/>
               </a:rPr>
-              <a:t>Conclusion &amp; Feuille de Route Gouvernance</a:t>
+              <a:t>Dashboard interactif — de l'exploration à l'action</a:t>
             </a:r>
           </a:p>
         </p:txBody>
@@ -10996,7 +12354,7 @@
         <p:spPr>
           <a:xfrm>
             <a:off x="457200" y="1280160"/>
-            <a:ext cx="5486400" cy="4937760"/>
+            <a:ext cx="6629400" cy="4937760"/>
           </a:xfrm>
           <a:prstGeom prst="rect">
             <a:avLst/>
@@ -11030,495 +12388,75 @@
           </a:p>
         </p:txBody>
       </p:sp>
-      <p:sp>
-        <p:nvSpPr>
-          <p:cNvPr id="8" name="TextBox 7"/>
-          <p:cNvSpPr txBox="1"/>
-          <p:nvPr/>
-        </p:nvSpPr>
-        <p:spPr>
-          <a:xfrm>
-            <a:off x="640080" y="1463040"/>
-            <a:ext cx="5120640" cy="365760"/>
-          </a:xfrm>
-          <a:prstGeom prst="rect">
-            <a:avLst/>
-          </a:prstGeom>
-          <a:noFill/>
-        </p:spPr>
-        <p:txBody>
-          <a:bodyPr wrap="square" anchor="t" lIns="50800" rIns="50800" tIns="50800" bIns="50800">
-            <a:spAutoFit/>
-          </a:bodyPr>
-          <a:lstStyle/>
-          <a:p>
-            <a:pPr algn="l"/>
-            <a:r>
-              <a:rPr sz="1500" b="1">
-                <a:solidFill>
-                  <a:srgbClr val="0B4F4A"/>
-                </a:solidFill>
-                <a:latin typeface="Poppins"/>
-              </a:rPr>
-              <a:t>Bilan Synthétique du Diagnostic</a:t>
-            </a:r>
-          </a:p>
-        </p:txBody>
-      </p:sp>
-      <p:sp>
-        <p:nvSpPr>
-          <p:cNvPr id="9" name="Rectangle 8"/>
+      <p:pic>
+        <p:nvPicPr>
+          <p:cNvPr id="8" name="Picture 7" descr="dashboard_preview.png"/>
+          <p:cNvPicPr>
+            <a:picLocks noChangeAspect="1"/>
+          </p:cNvPicPr>
+          <p:nvPr/>
+        </p:nvPicPr>
+        <p:blipFill>
+          <a:blip r:embed="rId3"/>
+          <a:stretch>
+            <a:fillRect/>
+          </a:stretch>
+        </p:blipFill>
+        <p:spPr>
+          <a:xfrm>
+            <a:off x="658368" y="1536192"/>
+            <a:ext cx="6236208" cy="4114165"/>
+          </a:xfrm>
+          <a:prstGeom prst="rect">
+            <a:avLst/>
+          </a:prstGeom>
+        </p:spPr>
+      </p:pic>
+      <p:sp>
+        <p:nvSpPr>
+          <p:cNvPr id="9" name="TextBox 8"/>
+          <p:cNvSpPr txBox="1"/>
+          <p:nvPr/>
+        </p:nvSpPr>
+        <p:spPr>
+          <a:xfrm>
+            <a:off x="658368" y="5687568"/>
+            <a:ext cx="6217920" cy="292608"/>
+          </a:xfrm>
+          <a:prstGeom prst="rect">
+            <a:avLst/>
+          </a:prstGeom>
+          <a:noFill/>
+        </p:spPr>
+        <p:txBody>
+          <a:bodyPr wrap="square" anchor="t" lIns="50800" rIns="50800" tIns="50800" bIns="50800">
+            <a:spAutoFit/>
+          </a:bodyPr>
+          <a:lstStyle/>
+          <a:p>
+            <a:pPr algn="l"/>
+            <a:r>
+              <a:rPr sz="950" b="0">
+                <a:solidFill>
+                  <a:srgbClr val="5D726E"/>
+                </a:solidFill>
+                <a:latin typeface="Poppins"/>
+              </a:rPr>
+              <a:t>Vue d'ensemble : filtres globaux, KPI, graphiques interprétés et accès aux sept vues analytiques.</a:t>
+            </a:r>
+          </a:p>
+        </p:txBody>
+      </p:sp>
+      <p:sp>
+        <p:nvSpPr>
+          <p:cNvPr id="10" name="Rectangle 9"/>
           <p:cNvSpPr/>
           <p:nvPr/>
         </p:nvSpPr>
         <p:spPr>
           <a:xfrm>
-            <a:off x="640080" y="1965960"/>
-            <a:ext cx="50800" cy="777240"/>
-          </a:xfrm>
-          <a:prstGeom prst="rect">
-            <a:avLst/>
-          </a:prstGeom>
-          <a:solidFill>
-            <a:srgbClr val="0B4F4A"/>
-          </a:solidFill>
-          <a:ln>
-            <a:noFill/>
-          </a:ln>
-          <a:effectLst/>
-        </p:spPr>
-        <p:style>
-          <a:lnRef idx="1">
-            <a:schemeClr val="accent1"/>
-          </a:lnRef>
-          <a:fillRef idx="3">
-            <a:schemeClr val="accent1"/>
-          </a:fillRef>
-          <a:fontRef idx="minor">
-            <a:schemeClr val="lt1"/>
-          </a:fontRef>
-        </p:style>
-        <p:txBody>
-          <a:bodyPr rtlCol="0" anchor="ctr"/>
-          <a:lstStyle/>
-          <a:p>
-            <a:pPr algn="ctr"/>
-          </a:p>
-        </p:txBody>
-      </p:sp>
-      <p:sp>
-        <p:nvSpPr>
-          <p:cNvPr id="10" name="TextBox 9"/>
-          <p:cNvSpPr txBox="1"/>
-          <p:nvPr/>
-        </p:nvSpPr>
-        <p:spPr>
-          <a:xfrm>
-            <a:off x="777240" y="1965960"/>
-            <a:ext cx="4937760" cy="274320"/>
-          </a:xfrm>
-          <a:prstGeom prst="rect">
-            <a:avLst/>
-          </a:prstGeom>
-          <a:noFill/>
-        </p:spPr>
-        <p:txBody>
-          <a:bodyPr wrap="square" anchor="t" lIns="50800" rIns="50800" tIns="50800" bIns="50800">
-            <a:spAutoFit/>
-          </a:bodyPr>
-          <a:lstStyle/>
-          <a:p>
-            <a:pPr algn="l"/>
-            <a:r>
-              <a:rPr sz="1200" b="1">
-                <a:solidFill>
-                  <a:srgbClr val="0B4F4A"/>
-                </a:solidFill>
-                <a:latin typeface="Poppins"/>
-              </a:rPr>
-              <a:t>Couverture Hétérogène</a:t>
-            </a:r>
-          </a:p>
-        </p:txBody>
-      </p:sp>
-      <p:sp>
-        <p:nvSpPr>
-          <p:cNvPr id="11" name="TextBox 10"/>
-          <p:cNvSpPr txBox="1"/>
-          <p:nvPr/>
-        </p:nvSpPr>
-        <p:spPr>
-          <a:xfrm>
-            <a:off x="777240" y="2221992"/>
-            <a:ext cx="4937760" cy="548640"/>
-          </a:xfrm>
-          <a:prstGeom prst="rect">
-            <a:avLst/>
-          </a:prstGeom>
-          <a:noFill/>
-        </p:spPr>
-        <p:txBody>
-          <a:bodyPr wrap="square" anchor="t" lIns="50800" rIns="50800" tIns="50800" bIns="50800">
-            <a:spAutoFit/>
-          </a:bodyPr>
-          <a:lstStyle/>
-          <a:p>
-            <a:pPr algn="l"/>
-            <a:r>
-              <a:rPr sz="1100" b="0">
-                <a:solidFill>
-                  <a:srgbClr val="16302C"/>
-                </a:solidFill>
-                <a:latin typeface="Poppins"/>
-              </a:rPr>
-              <a:t>Forte disparité spatiale entre la région Maritime (TdE) et le corridor Nord (COSO).</a:t>
-            </a:r>
-          </a:p>
-        </p:txBody>
-      </p:sp>
-      <p:sp>
-        <p:nvSpPr>
-          <p:cNvPr id="12" name="Rectangle 11"/>
-          <p:cNvSpPr/>
-          <p:nvPr/>
-        </p:nvSpPr>
-        <p:spPr>
-          <a:xfrm>
-            <a:off x="640080" y="3017520"/>
-            <a:ext cx="50800" cy="777240"/>
-          </a:xfrm>
-          <a:prstGeom prst="rect">
-            <a:avLst/>
-          </a:prstGeom>
-          <a:solidFill>
-            <a:srgbClr val="0B4F4A"/>
-          </a:solidFill>
-          <a:ln>
-            <a:noFill/>
-          </a:ln>
-          <a:effectLst/>
-        </p:spPr>
-        <p:style>
-          <a:lnRef idx="1">
-            <a:schemeClr val="accent1"/>
-          </a:lnRef>
-          <a:fillRef idx="3">
-            <a:schemeClr val="accent1"/>
-          </a:fillRef>
-          <a:fontRef idx="minor">
-            <a:schemeClr val="lt1"/>
-          </a:fontRef>
-        </p:style>
-        <p:txBody>
-          <a:bodyPr rtlCol="0" anchor="ctr"/>
-          <a:lstStyle/>
-          <a:p>
-            <a:pPr algn="ctr"/>
-          </a:p>
-        </p:txBody>
-      </p:sp>
-      <p:sp>
-        <p:nvSpPr>
-          <p:cNvPr id="13" name="TextBox 12"/>
-          <p:cNvSpPr txBox="1"/>
-          <p:nvPr/>
-        </p:nvSpPr>
-        <p:spPr>
-          <a:xfrm>
-            <a:off x="777240" y="3017520"/>
-            <a:ext cx="4937760" cy="274320"/>
-          </a:xfrm>
-          <a:prstGeom prst="rect">
-            <a:avLst/>
-          </a:prstGeom>
-          <a:noFill/>
-        </p:spPr>
-        <p:txBody>
-          <a:bodyPr wrap="square" anchor="t" lIns="50800" rIns="50800" tIns="50800" bIns="50800">
-            <a:spAutoFit/>
-          </a:bodyPr>
-          <a:lstStyle/>
-          <a:p>
-            <a:pPr algn="l"/>
-            <a:r>
-              <a:rPr sz="1200" b="1">
-                <a:solidFill>
-                  <a:srgbClr val="0B4F4A"/>
-                </a:solidFill>
-                <a:latin typeface="Poppins"/>
-              </a:rPr>
-              <a:t>Durabilité à Sécuriser</a:t>
-            </a:r>
-          </a:p>
-        </p:txBody>
-      </p:sp>
-      <p:sp>
-        <p:nvSpPr>
-          <p:cNvPr id="14" name="TextBox 13"/>
-          <p:cNvSpPr txBox="1"/>
-          <p:nvPr/>
-        </p:nvSpPr>
-        <p:spPr>
-          <a:xfrm>
-            <a:off x="777240" y="3273552"/>
-            <a:ext cx="4937760" cy="548640"/>
-          </a:xfrm>
-          <a:prstGeom prst="rect">
-            <a:avLst/>
-          </a:prstGeom>
-          <a:noFill/>
-        </p:spPr>
-        <p:txBody>
-          <a:bodyPr wrap="square" anchor="t" lIns="50800" rIns="50800" tIns="50800" bIns="50800">
-            <a:spAutoFit/>
-          </a:bodyPr>
-          <a:lstStyle/>
-          <a:p>
-            <a:pPr algn="l"/>
-            <a:r>
-              <a:rPr sz="1100" b="0">
-                <a:solidFill>
-                  <a:srgbClr val="16302C"/>
-                </a:solidFill>
-                <a:latin typeface="Poppins"/>
-              </a:rPr>
-              <a:t>Seuls 20.6 % des ouvrages COSO ont un plan d'entretien documenté, nécessitant un suivi rigoureux.</a:t>
-            </a:r>
-          </a:p>
-        </p:txBody>
-      </p:sp>
-      <p:sp>
-        <p:nvSpPr>
-          <p:cNvPr id="15" name="Rectangle 14"/>
-          <p:cNvSpPr/>
-          <p:nvPr/>
-        </p:nvSpPr>
-        <p:spPr>
-          <a:xfrm>
-            <a:off x="640080" y="4069080"/>
-            <a:ext cx="50800" cy="777240"/>
-          </a:xfrm>
-          <a:prstGeom prst="rect">
-            <a:avLst/>
-          </a:prstGeom>
-          <a:solidFill>
-            <a:srgbClr val="0B4F4A"/>
-          </a:solidFill>
-          <a:ln>
-            <a:noFill/>
-          </a:ln>
-          <a:effectLst/>
-        </p:spPr>
-        <p:style>
-          <a:lnRef idx="1">
-            <a:schemeClr val="accent1"/>
-          </a:lnRef>
-          <a:fillRef idx="3">
-            <a:schemeClr val="accent1"/>
-          </a:fillRef>
-          <a:fontRef idx="minor">
-            <a:schemeClr val="lt1"/>
-          </a:fontRef>
-        </p:style>
-        <p:txBody>
-          <a:bodyPr rtlCol="0" anchor="ctr"/>
-          <a:lstStyle/>
-          <a:p>
-            <a:pPr algn="ctr"/>
-          </a:p>
-        </p:txBody>
-      </p:sp>
-      <p:sp>
-        <p:nvSpPr>
-          <p:cNvPr id="16" name="TextBox 15"/>
-          <p:cNvSpPr txBox="1"/>
-          <p:nvPr/>
-        </p:nvSpPr>
-        <p:spPr>
-          <a:xfrm>
-            <a:off x="777240" y="4069080"/>
-            <a:ext cx="4937760" cy="274320"/>
-          </a:xfrm>
-          <a:prstGeom prst="rect">
-            <a:avLst/>
-          </a:prstGeom>
-          <a:noFill/>
-        </p:spPr>
-        <p:txBody>
-          <a:bodyPr wrap="square" anchor="t" lIns="50800" rIns="50800" tIns="50800" bIns="50800">
-            <a:spAutoFit/>
-          </a:bodyPr>
-          <a:lstStyle/>
-          <a:p>
-            <a:pPr algn="l"/>
-            <a:r>
-              <a:rPr sz="1200" b="1">
-                <a:solidFill>
-                  <a:srgbClr val="0B4F4A"/>
-                </a:solidFill>
-                <a:latin typeface="Poppins"/>
-              </a:rPr>
-              <a:t>Vulnérabilité Climatique</a:t>
-            </a:r>
-          </a:p>
-        </p:txBody>
-      </p:sp>
-      <p:sp>
-        <p:nvSpPr>
-          <p:cNvPr id="17" name="TextBox 16"/>
-          <p:cNvSpPr txBox="1"/>
-          <p:nvPr/>
-        </p:nvSpPr>
-        <p:spPr>
-          <a:xfrm>
-            <a:off x="777240" y="4325112"/>
-            <a:ext cx="4937760" cy="548640"/>
-          </a:xfrm>
-          <a:prstGeom prst="rect">
-            <a:avLst/>
-          </a:prstGeom>
-          <a:noFill/>
-        </p:spPr>
-        <p:txBody>
-          <a:bodyPr wrap="square" anchor="t" lIns="50800" rIns="50800" tIns="50800" bIns="50800">
-            <a:spAutoFit/>
-          </a:bodyPr>
-          <a:lstStyle/>
-          <a:p>
-            <a:pPr algn="l"/>
-            <a:r>
-              <a:rPr sz="1100" b="0">
-                <a:solidFill>
-                  <a:srgbClr val="16302C"/>
-                </a:solidFill>
-                <a:latin typeface="Poppins"/>
-              </a:rPr>
-              <a:t>77 ouvrages géolocalisés sont exposés à un risque d'inondation élevé (FRI &gt; 0.13).</a:t>
-            </a:r>
-          </a:p>
-        </p:txBody>
-      </p:sp>
-      <p:sp>
-        <p:nvSpPr>
-          <p:cNvPr id="18" name="Rectangle 17"/>
-          <p:cNvSpPr/>
-          <p:nvPr/>
-        </p:nvSpPr>
-        <p:spPr>
-          <a:xfrm>
-            <a:off x="640080" y="5120640"/>
-            <a:ext cx="50800" cy="777240"/>
-          </a:xfrm>
-          <a:prstGeom prst="rect">
-            <a:avLst/>
-          </a:prstGeom>
-          <a:solidFill>
-            <a:srgbClr val="0B4F4A"/>
-          </a:solidFill>
-          <a:ln>
-            <a:noFill/>
-          </a:ln>
-          <a:effectLst/>
-        </p:spPr>
-        <p:style>
-          <a:lnRef idx="1">
-            <a:schemeClr val="accent1"/>
-          </a:lnRef>
-          <a:fillRef idx="3">
-            <a:schemeClr val="accent1"/>
-          </a:fillRef>
-          <a:fontRef idx="minor">
-            <a:schemeClr val="lt1"/>
-          </a:fontRef>
-        </p:style>
-        <p:txBody>
-          <a:bodyPr rtlCol="0" anchor="ctr"/>
-          <a:lstStyle/>
-          <a:p>
-            <a:pPr algn="ctr"/>
-          </a:p>
-        </p:txBody>
-      </p:sp>
-      <p:sp>
-        <p:nvSpPr>
-          <p:cNvPr id="19" name="TextBox 18"/>
-          <p:cNvSpPr txBox="1"/>
-          <p:nvPr/>
-        </p:nvSpPr>
-        <p:spPr>
-          <a:xfrm>
-            <a:off x="777240" y="5120640"/>
-            <a:ext cx="4937760" cy="274320"/>
-          </a:xfrm>
-          <a:prstGeom prst="rect">
-            <a:avLst/>
-          </a:prstGeom>
-          <a:noFill/>
-        </p:spPr>
-        <p:txBody>
-          <a:bodyPr wrap="square" anchor="t" lIns="50800" rIns="50800" tIns="50800" bIns="50800">
-            <a:spAutoFit/>
-          </a:bodyPr>
-          <a:lstStyle/>
-          <a:p>
-            <a:pPr algn="l"/>
-            <a:r>
-              <a:rPr sz="1200" b="1">
-                <a:solidFill>
-                  <a:srgbClr val="0B4F4A"/>
-                </a:solidFill>
-                <a:latin typeface="Poppins"/>
-              </a:rPr>
-              <a:t>Livrables Opérationnels</a:t>
-            </a:r>
-          </a:p>
-        </p:txBody>
-      </p:sp>
-      <p:sp>
-        <p:nvSpPr>
-          <p:cNvPr id="20" name="TextBox 19"/>
-          <p:cNvSpPr txBox="1"/>
-          <p:nvPr/>
-        </p:nvSpPr>
-        <p:spPr>
-          <a:xfrm>
-            <a:off x="777240" y="5376672"/>
-            <a:ext cx="4937760" cy="548640"/>
-          </a:xfrm>
-          <a:prstGeom prst="rect">
-            <a:avLst/>
-          </a:prstGeom>
-          <a:noFill/>
-        </p:spPr>
-        <p:txBody>
-          <a:bodyPr wrap="square" anchor="t" lIns="50800" rIns="50800" tIns="50800" bIns="50800">
-            <a:spAutoFit/>
-          </a:bodyPr>
-          <a:lstStyle/>
-          <a:p>
-            <a:pPr algn="l"/>
-            <a:r>
-              <a:rPr sz="1100" b="0">
-                <a:solidFill>
-                  <a:srgbClr val="16302C"/>
-                </a:solidFill>
-                <a:latin typeface="Poppins"/>
-              </a:rPr>
-              <a:t>Un dashboard interactif fonctionnel (.zip) et ce rapport d'analyse pour guider les décideurs.</a:t>
-            </a:r>
-          </a:p>
-        </p:txBody>
-      </p:sp>
-      <p:sp>
-        <p:nvSpPr>
-          <p:cNvPr id="21" name="Rectangle 20"/>
-          <p:cNvSpPr/>
-          <p:nvPr/>
-        </p:nvSpPr>
-        <p:spPr>
-          <a:xfrm>
-            <a:off x="6217920" y="1280160"/>
-            <a:ext cx="5486400" cy="4937760"/>
+            <a:off x="7315200" y="1280160"/>
+            <a:ext cx="4389120" cy="4937760"/>
           </a:xfrm>
           <a:prstGeom prst="rect">
             <a:avLst/>
@@ -11554,14 +12492,14 @@
       </p:sp>
       <p:sp>
         <p:nvSpPr>
-          <p:cNvPr id="22" name="TextBox 21"/>
-          <p:cNvSpPr txBox="1"/>
-          <p:nvPr/>
-        </p:nvSpPr>
-        <p:spPr>
-          <a:xfrm>
-            <a:off x="6400800" y="1463040"/>
-            <a:ext cx="5120640" cy="365760"/>
+          <p:cNvPr id="11" name="TextBox 10"/>
+          <p:cNvSpPr txBox="1"/>
+          <p:nvPr/>
+        </p:nvSpPr>
+        <p:spPr>
+          <a:xfrm>
+            <a:off x="7543800" y="1481328"/>
+            <a:ext cx="3931920" cy="365760"/>
           </a:xfrm>
           <a:prstGeom prst="rect">
             <a:avLst/>
@@ -11582,32 +12520,30 @@
                 </a:solidFill>
                 <a:latin typeface="Poppins"/>
               </a:rPr>
-              <a:t>Feuille de Route pour la Gouvernance</a:t>
-            </a:r>
-          </a:p>
-        </p:txBody>
-      </p:sp>
-      <p:sp>
-        <p:nvSpPr>
-          <p:cNvPr id="23" name="Rectangle 22"/>
+              <a:t>Fonctionnalités livrées</a:t>
+            </a:r>
+          </a:p>
+        </p:txBody>
+      </p:sp>
+      <p:sp>
+        <p:nvSpPr>
+          <p:cNvPr id="12" name="Rectangle 11"/>
           <p:cNvSpPr/>
           <p:nvPr/>
         </p:nvSpPr>
         <p:spPr>
           <a:xfrm>
-            <a:off x="6400800" y="1965960"/>
-            <a:ext cx="5120640" cy="822960"/>
+            <a:off x="7543800" y="2011680"/>
+            <a:ext cx="50800" cy="658368"/>
           </a:xfrm>
           <a:prstGeom prst="rect">
             <a:avLst/>
           </a:prstGeom>
           <a:solidFill>
-            <a:srgbClr val="FFFFFF"/>
+            <a:srgbClr val="14877D"/>
           </a:solidFill>
-          <a:ln w="7620">
-            <a:solidFill>
-              <a:srgbClr val="E0EBE8"/>
-            </a:solidFill>
+          <a:ln>
+            <a:noFill/>
           </a:ln>
           <a:effectLst/>
         </p:spPr>
@@ -11632,95 +12568,93 @@
       </p:sp>
       <p:sp>
         <p:nvSpPr>
-          <p:cNvPr id="24" name="TextBox 23"/>
-          <p:cNvSpPr txBox="1"/>
-          <p:nvPr/>
-        </p:nvSpPr>
-        <p:spPr>
-          <a:xfrm>
-            <a:off x="6583680" y="2075688"/>
-            <a:ext cx="4754880" cy="274320"/>
-          </a:xfrm>
-          <a:prstGeom prst="rect">
-            <a:avLst/>
-          </a:prstGeom>
-          <a:noFill/>
-        </p:spPr>
-        <p:txBody>
-          <a:bodyPr wrap="square" anchor="t" lIns="50800" rIns="50800" tIns="50800" bIns="50800">
-            <a:spAutoFit/>
-          </a:bodyPr>
-          <a:lstStyle/>
-          <a:p>
-            <a:pPr algn="l"/>
-            <a:r>
-              <a:rPr sz="1200" b="1">
-                <a:solidFill>
-                  <a:srgbClr val="14877D"/>
-                </a:solidFill>
-                <a:latin typeface="Poppins"/>
-              </a:rPr>
-              <a:t>Étape 1 : Standardisation</a:t>
-            </a:r>
-          </a:p>
-        </p:txBody>
-      </p:sp>
-      <p:sp>
-        <p:nvSpPr>
-          <p:cNvPr id="25" name="TextBox 24"/>
-          <p:cNvSpPr txBox="1"/>
-          <p:nvPr/>
-        </p:nvSpPr>
-        <p:spPr>
-          <a:xfrm>
-            <a:off x="6583680" y="2331720"/>
-            <a:ext cx="4754880" cy="411480"/>
-          </a:xfrm>
-          <a:prstGeom prst="rect">
-            <a:avLst/>
-          </a:prstGeom>
-          <a:noFill/>
-        </p:spPr>
-        <p:txBody>
-          <a:bodyPr wrap="square" anchor="t" lIns="50800" rIns="50800" tIns="50800" bIns="50800">
-            <a:spAutoFit/>
-          </a:bodyPr>
-          <a:lstStyle/>
-          <a:p>
-            <a:pPr algn="l"/>
-            <a:r>
-              <a:rPr sz="1100" b="0">
+          <p:cNvPr id="13" name="TextBox 12"/>
+          <p:cNvSpPr txBox="1"/>
+          <p:nvPr/>
+        </p:nvSpPr>
+        <p:spPr>
+          <a:xfrm>
+            <a:off x="7699248" y="2011680"/>
+            <a:ext cx="3657600" cy="228600"/>
+          </a:xfrm>
+          <a:prstGeom prst="rect">
+            <a:avLst/>
+          </a:prstGeom>
+          <a:noFill/>
+        </p:spPr>
+        <p:txBody>
+          <a:bodyPr wrap="square" anchor="t" lIns="50800" rIns="50800" tIns="50800" bIns="50800">
+            <a:spAutoFit/>
+          </a:bodyPr>
+          <a:lstStyle/>
+          <a:p>
+            <a:pPr algn="l"/>
+            <a:r>
+              <a:rPr sz="1150" b="1">
+                <a:solidFill>
+                  <a:srgbClr val="0B4F4A"/>
+                </a:solidFill>
+                <a:latin typeface="Poppins"/>
+              </a:rPr>
+              <a:t>Filtres transversaux</a:t>
+            </a:r>
+          </a:p>
+        </p:txBody>
+      </p:sp>
+      <p:sp>
+        <p:nvSpPr>
+          <p:cNvPr id="14" name="TextBox 13"/>
+          <p:cNvSpPr txBox="1"/>
+          <p:nvPr/>
+        </p:nvSpPr>
+        <p:spPr>
+          <a:xfrm>
+            <a:off x="7699248" y="2231136"/>
+            <a:ext cx="3657600" cy="411480"/>
+          </a:xfrm>
+          <a:prstGeom prst="rect">
+            <a:avLst/>
+          </a:prstGeom>
+          <a:noFill/>
+        </p:spPr>
+        <p:txBody>
+          <a:bodyPr wrap="square" anchor="t" lIns="50800" rIns="50800" tIns="50800" bIns="50800">
+            <a:spAutoFit/>
+          </a:bodyPr>
+          <a:lstStyle/>
+          <a:p>
+            <a:pPr algn="l"/>
+            <a:r>
+              <a:rPr sz="1000" b="0">
                 <a:solidFill>
                   <a:srgbClr val="16302C"/>
                 </a:solidFill>
                 <a:latin typeface="Poppins"/>
               </a:rPr>
-              <a:t>Instaurer un schéma géographique commun (GPS, codes cantons) pour tous les projets d'eau.</a:t>
-            </a:r>
-          </a:p>
-        </p:txBody>
-      </p:sp>
-      <p:sp>
-        <p:nvSpPr>
-          <p:cNvPr id="26" name="Rectangle 25"/>
+              <a:t>Régions multiples, sources TdE/COSO, classes FRI et recherche par ouvrage ou canton.</a:t>
+            </a:r>
+          </a:p>
+        </p:txBody>
+      </p:sp>
+      <p:sp>
+        <p:nvSpPr>
+          <p:cNvPr id="15" name="Rectangle 14"/>
           <p:cNvSpPr/>
           <p:nvPr/>
         </p:nvSpPr>
         <p:spPr>
           <a:xfrm>
-            <a:off x="6400800" y="3017520"/>
-            <a:ext cx="5120640" cy="822960"/>
+            <a:off x="7543800" y="2816352"/>
+            <a:ext cx="50800" cy="658368"/>
           </a:xfrm>
           <a:prstGeom prst="rect">
             <a:avLst/>
           </a:prstGeom>
           <a:solidFill>
-            <a:srgbClr val="FFFFFF"/>
+            <a:srgbClr val="14877D"/>
           </a:solidFill>
-          <a:ln w="7620">
-            <a:solidFill>
-              <a:srgbClr val="E0EBE8"/>
-            </a:solidFill>
+          <a:ln>
+            <a:noFill/>
           </a:ln>
           <a:effectLst/>
         </p:spPr>
@@ -11745,95 +12679,93 @@
       </p:sp>
       <p:sp>
         <p:nvSpPr>
-          <p:cNvPr id="27" name="TextBox 26"/>
-          <p:cNvSpPr txBox="1"/>
-          <p:nvPr/>
-        </p:nvSpPr>
-        <p:spPr>
-          <a:xfrm>
-            <a:off x="6583680" y="3127248"/>
-            <a:ext cx="4754880" cy="274320"/>
-          </a:xfrm>
-          <a:prstGeom prst="rect">
-            <a:avLst/>
-          </a:prstGeom>
-          <a:noFill/>
-        </p:spPr>
-        <p:txBody>
-          <a:bodyPr wrap="square" anchor="t" lIns="50800" rIns="50800" tIns="50800" bIns="50800">
-            <a:spAutoFit/>
-          </a:bodyPr>
-          <a:lstStyle/>
-          <a:p>
-            <a:pPr algn="l"/>
-            <a:r>
-              <a:rPr sz="1200" b="1">
-                <a:solidFill>
-                  <a:srgbClr val="14877D"/>
-                </a:solidFill>
-                <a:latin typeface="Poppins"/>
-              </a:rPr>
-              <a:t>Étape 2 : Campagne Terrain</a:t>
-            </a:r>
-          </a:p>
-        </p:txBody>
-      </p:sp>
-      <p:sp>
-        <p:nvSpPr>
-          <p:cNvPr id="28" name="TextBox 27"/>
-          <p:cNvSpPr txBox="1"/>
-          <p:nvPr/>
-        </p:nvSpPr>
-        <p:spPr>
-          <a:xfrm>
-            <a:off x="6583680" y="3383280"/>
-            <a:ext cx="4754880" cy="411480"/>
-          </a:xfrm>
-          <a:prstGeom prst="rect">
-            <a:avLst/>
-          </a:prstGeom>
-          <a:noFill/>
-        </p:spPr>
-        <p:txBody>
-          <a:bodyPr wrap="square" anchor="t" lIns="50800" rIns="50800" tIns="50800" bIns="50800">
-            <a:spAutoFit/>
-          </a:bodyPr>
-          <a:lstStyle/>
-          <a:p>
-            <a:pPr algn="l"/>
-            <a:r>
-              <a:rPr sz="1100" b="0">
+          <p:cNvPr id="16" name="TextBox 15"/>
+          <p:cNvSpPr txBox="1"/>
+          <p:nvPr/>
+        </p:nvSpPr>
+        <p:spPr>
+          <a:xfrm>
+            <a:off x="7699248" y="2816352"/>
+            <a:ext cx="3657600" cy="228600"/>
+          </a:xfrm>
+          <a:prstGeom prst="rect">
+            <a:avLst/>
+          </a:prstGeom>
+          <a:noFill/>
+        </p:spPr>
+        <p:txBody>
+          <a:bodyPr wrap="square" anchor="t" lIns="50800" rIns="50800" tIns="50800" bIns="50800">
+            <a:spAutoFit/>
+          </a:bodyPr>
+          <a:lstStyle/>
+          <a:p>
+            <a:pPr algn="l"/>
+            <a:r>
+              <a:rPr sz="1150" b="1">
+                <a:solidFill>
+                  <a:srgbClr val="0B4F4A"/>
+                </a:solidFill>
+                <a:latin typeface="Poppins"/>
+              </a:rPr>
+              <a:t>Cartographie SIG</a:t>
+            </a:r>
+          </a:p>
+        </p:txBody>
+      </p:sp>
+      <p:sp>
+        <p:nvSpPr>
+          <p:cNvPr id="17" name="TextBox 16"/>
+          <p:cNvSpPr txBox="1"/>
+          <p:nvPr/>
+        </p:nvSpPr>
+        <p:spPr>
+          <a:xfrm>
+            <a:off x="7699248" y="3035808"/>
+            <a:ext cx="3657600" cy="411480"/>
+          </a:xfrm>
+          <a:prstGeom prst="rect">
+            <a:avLst/>
+          </a:prstGeom>
+          <a:noFill/>
+        </p:spPr>
+        <p:txBody>
+          <a:bodyPr wrap="square" anchor="t" lIns="50800" rIns="50800" tIns="50800" bIns="50800">
+            <a:spAutoFit/>
+          </a:bodyPr>
+          <a:lstStyle/>
+          <a:p>
+            <a:pPr algn="l"/>
+            <a:r>
+              <a:rPr sz="1000" b="0">
                 <a:solidFill>
                   <a:srgbClr val="16302C"/>
                 </a:solidFill>
                 <a:latin typeface="Poppins"/>
               </a:rPr>
-              <a:t>Déployer un contrôle physique sur les 115 ouvrages identifiés en priorité de contrôle.</a:t>
-            </a:r>
-          </a:p>
-        </p:txBody>
-      </p:sp>
-      <p:sp>
-        <p:nvSpPr>
-          <p:cNvPr id="29" name="Rectangle 28"/>
+              <a:t>Croisement FRI × ouvrages, légende visible, couches TdE/COSO et fond hors ligne.</a:t>
+            </a:r>
+          </a:p>
+        </p:txBody>
+      </p:sp>
+      <p:sp>
+        <p:nvSpPr>
+          <p:cNvPr id="18" name="Rectangle 17"/>
           <p:cNvSpPr/>
           <p:nvPr/>
         </p:nvSpPr>
         <p:spPr>
           <a:xfrm>
-            <a:off x="6400800" y="4069080"/>
-            <a:ext cx="5120640" cy="822960"/>
+            <a:off x="7543800" y="3621024"/>
+            <a:ext cx="50800" cy="658368"/>
           </a:xfrm>
           <a:prstGeom prst="rect">
             <a:avLst/>
           </a:prstGeom>
           <a:solidFill>
-            <a:srgbClr val="FFFFFF"/>
+            <a:srgbClr val="14877D"/>
           </a:solidFill>
-          <a:ln w="7620">
-            <a:solidFill>
-              <a:srgbClr val="E0EBE8"/>
-            </a:solidFill>
+          <a:ln>
+            <a:noFill/>
           </a:ln>
           <a:effectLst/>
         </p:spPr>
@@ -11858,95 +12790,93 @@
       </p:sp>
       <p:sp>
         <p:nvSpPr>
-          <p:cNvPr id="30" name="TextBox 29"/>
-          <p:cNvSpPr txBox="1"/>
-          <p:nvPr/>
-        </p:nvSpPr>
-        <p:spPr>
-          <a:xfrm>
-            <a:off x="6583680" y="4178808"/>
-            <a:ext cx="4754880" cy="274320"/>
-          </a:xfrm>
-          <a:prstGeom prst="rect">
-            <a:avLst/>
-          </a:prstGeom>
-          <a:noFill/>
-        </p:spPr>
-        <p:txBody>
-          <a:bodyPr wrap="square" anchor="t" lIns="50800" rIns="50800" tIns="50800" bIns="50800">
-            <a:spAutoFit/>
-          </a:bodyPr>
-          <a:lstStyle/>
-          <a:p>
-            <a:pPr algn="l"/>
-            <a:r>
-              <a:rPr sz="1200" b="1">
-                <a:solidFill>
-                  <a:srgbClr val="14877D"/>
-                </a:solidFill>
-                <a:latin typeface="Poppins"/>
-              </a:rPr>
-              <a:t>Étape 3 : Interconnexion Portail</a:t>
-            </a:r>
-          </a:p>
-        </p:txBody>
-      </p:sp>
-      <p:sp>
-        <p:nvSpPr>
-          <p:cNvPr id="31" name="TextBox 30"/>
-          <p:cNvSpPr txBox="1"/>
-          <p:nvPr/>
-        </p:nvSpPr>
-        <p:spPr>
-          <a:xfrm>
-            <a:off x="6583680" y="4434840"/>
-            <a:ext cx="4754880" cy="411480"/>
-          </a:xfrm>
-          <a:prstGeom prst="rect">
-            <a:avLst/>
-          </a:prstGeom>
-          <a:noFill/>
-        </p:spPr>
-        <p:txBody>
-          <a:bodyPr wrap="square" anchor="t" lIns="50800" rIns="50800" tIns="50800" bIns="50800">
-            <a:spAutoFit/>
-          </a:bodyPr>
-          <a:lstStyle/>
-          <a:p>
-            <a:pPr algn="l"/>
-            <a:r>
-              <a:rPr sz="1100" b="0">
+          <p:cNvPr id="19" name="TextBox 18"/>
+          <p:cNvSpPr txBox="1"/>
+          <p:nvPr/>
+        </p:nvSpPr>
+        <p:spPr>
+          <a:xfrm>
+            <a:off x="7699248" y="3621024"/>
+            <a:ext cx="3657600" cy="228600"/>
+          </a:xfrm>
+          <a:prstGeom prst="rect">
+            <a:avLst/>
+          </a:prstGeom>
+          <a:noFill/>
+        </p:spPr>
+        <p:txBody>
+          <a:bodyPr wrap="square" anchor="t" lIns="50800" rIns="50800" tIns="50800" bIns="50800">
+            <a:spAutoFit/>
+          </a:bodyPr>
+          <a:lstStyle/>
+          <a:p>
+            <a:pPr algn="l"/>
+            <a:r>
+              <a:rPr sz="1150" b="1">
+                <a:solidFill>
+                  <a:srgbClr val="0B4F4A"/>
+                </a:solidFill>
+                <a:latin typeface="Poppins"/>
+              </a:rPr>
+              <a:t>Analyses guidées</a:t>
+            </a:r>
+          </a:p>
+        </p:txBody>
+      </p:sp>
+      <p:sp>
+        <p:nvSpPr>
+          <p:cNvPr id="20" name="TextBox 19"/>
+          <p:cNvSpPr txBox="1"/>
+          <p:nvPr/>
+        </p:nvSpPr>
+        <p:spPr>
+          <a:xfrm>
+            <a:off x="7699248" y="3840480"/>
+            <a:ext cx="3657600" cy="411480"/>
+          </a:xfrm>
+          <a:prstGeom prst="rect">
+            <a:avLst/>
+          </a:prstGeom>
+          <a:noFill/>
+        </p:spPr>
+        <p:txBody>
+          <a:bodyPr wrap="square" anchor="t" lIns="50800" rIns="50800" tIns="50800" bIns="50800">
+            <a:spAutoFit/>
+          </a:bodyPr>
+          <a:lstStyle/>
+          <a:p>
+            <a:pPr algn="l"/>
+            <a:r>
+              <a:rPr sz="1000" b="0">
                 <a:solidFill>
                   <a:srgbClr val="16302C"/>
                 </a:solidFill>
                 <a:latin typeface="Poppins"/>
               </a:rPr>
-              <a:t>Mettre à jour et unifier les jeux TdE, COSO et Ministère sur l'écosystème opendata.gouv.tg.</a:t>
-            </a:r>
-          </a:p>
-        </p:txBody>
-      </p:sp>
-      <p:sp>
-        <p:nvSpPr>
-          <p:cNvPr id="32" name="Rectangle 31"/>
+              <a:t>Interprétation de chaque graphique et distinction entre faits observés et proxies.</a:t>
+            </a:r>
+          </a:p>
+        </p:txBody>
+      </p:sp>
+      <p:sp>
+        <p:nvSpPr>
+          <p:cNvPr id="21" name="Rectangle 20"/>
           <p:cNvSpPr/>
           <p:nvPr/>
         </p:nvSpPr>
         <p:spPr>
           <a:xfrm>
-            <a:off x="6400800" y="5120640"/>
-            <a:ext cx="5120640" cy="822960"/>
+            <a:off x="7543800" y="4425696"/>
+            <a:ext cx="50800" cy="658368"/>
           </a:xfrm>
           <a:prstGeom prst="rect">
             <a:avLst/>
           </a:prstGeom>
           <a:solidFill>
-            <a:srgbClr val="FFFFFF"/>
+            <a:srgbClr val="14877D"/>
           </a:solidFill>
-          <a:ln w="7620">
-            <a:solidFill>
-              <a:srgbClr val="E0EBE8"/>
-            </a:solidFill>
+          <a:ln>
+            <a:noFill/>
           </a:ln>
           <a:effectLst/>
         </p:spPr>
@@ -11971,77 +12901,188 @@
       </p:sp>
       <p:sp>
         <p:nvSpPr>
-          <p:cNvPr id="33" name="TextBox 32"/>
-          <p:cNvSpPr txBox="1"/>
-          <p:nvPr/>
-        </p:nvSpPr>
-        <p:spPr>
-          <a:xfrm>
-            <a:off x="6583680" y="5230368"/>
-            <a:ext cx="4754880" cy="274320"/>
-          </a:xfrm>
-          <a:prstGeom prst="rect">
-            <a:avLst/>
-          </a:prstGeom>
-          <a:noFill/>
-        </p:spPr>
-        <p:txBody>
-          <a:bodyPr wrap="square" anchor="t" lIns="50800" rIns="50800" tIns="50800" bIns="50800">
-            <a:spAutoFit/>
-          </a:bodyPr>
-          <a:lstStyle/>
-          <a:p>
-            <a:pPr algn="l"/>
-            <a:r>
-              <a:rPr sz="1200" b="1">
-                <a:solidFill>
-                  <a:srgbClr val="14877D"/>
-                </a:solidFill>
-                <a:latin typeface="Poppins"/>
-              </a:rPr>
-              <a:t>Étape 4 : Suivi d'Impact</a:t>
-            </a:r>
-          </a:p>
-        </p:txBody>
-      </p:sp>
-      <p:sp>
-        <p:nvSpPr>
-          <p:cNvPr id="34" name="TextBox 33"/>
-          <p:cNvSpPr txBox="1"/>
-          <p:nvPr/>
-        </p:nvSpPr>
-        <p:spPr>
-          <a:xfrm>
-            <a:off x="6583680" y="5486400"/>
-            <a:ext cx="4754880" cy="411480"/>
-          </a:xfrm>
-          <a:prstGeom prst="rect">
-            <a:avLst/>
-          </a:prstGeom>
-          <a:noFill/>
-        </p:spPr>
-        <p:txBody>
-          <a:bodyPr wrap="square" anchor="t" lIns="50800" rIns="50800" tIns="50800" bIns="50800">
-            <a:spAutoFit/>
-          </a:bodyPr>
-          <a:lstStyle/>
-          <a:p>
-            <a:pPr algn="l"/>
-            <a:r>
-              <a:rPr sz="1100" b="0">
+          <p:cNvPr id="22" name="TextBox 21"/>
+          <p:cNvSpPr txBox="1"/>
+          <p:nvPr/>
+        </p:nvSpPr>
+        <p:spPr>
+          <a:xfrm>
+            <a:off x="7699248" y="4425696"/>
+            <a:ext cx="3657600" cy="228600"/>
+          </a:xfrm>
+          <a:prstGeom prst="rect">
+            <a:avLst/>
+          </a:prstGeom>
+          <a:noFill/>
+        </p:spPr>
+        <p:txBody>
+          <a:bodyPr wrap="square" anchor="t" lIns="50800" rIns="50800" tIns="50800" bIns="50800">
+            <a:spAutoFit/>
+          </a:bodyPr>
+          <a:lstStyle/>
+          <a:p>
+            <a:pPr algn="l"/>
+            <a:r>
+              <a:rPr sz="1150" b="1">
+                <a:solidFill>
+                  <a:srgbClr val="0B4F4A"/>
+                </a:solidFill>
+                <a:latin typeface="Poppins"/>
+              </a:rPr>
+              <a:t>Exports décisionnels</a:t>
+            </a:r>
+          </a:p>
+        </p:txBody>
+      </p:sp>
+      <p:sp>
+        <p:nvSpPr>
+          <p:cNvPr id="23" name="TextBox 22"/>
+          <p:cNvSpPr txBox="1"/>
+          <p:nvPr/>
+        </p:nvSpPr>
+        <p:spPr>
+          <a:xfrm>
+            <a:off x="7699248" y="4645152"/>
+            <a:ext cx="3657600" cy="411480"/>
+          </a:xfrm>
+          <a:prstGeom prst="rect">
+            <a:avLst/>
+          </a:prstGeom>
+          <a:noFill/>
+        </p:spPr>
+        <p:txBody>
+          <a:bodyPr wrap="square" anchor="t" lIns="50800" rIns="50800" tIns="50800" bIns="50800">
+            <a:spAutoFit/>
+          </a:bodyPr>
+          <a:lstStyle/>
+          <a:p>
+            <a:pPr algn="l"/>
+            <a:r>
+              <a:rPr sz="1000" b="0">
                 <a:solidFill>
                   <a:srgbClr val="16302C"/>
                 </a:solidFill>
                 <a:latin typeface="Poppins"/>
               </a:rPr>
-              <a:t>Mesurer le taux de desserte effectif et la fonctionnalité réelle au niveau canton.</a:t>
-            </a:r>
-          </a:p>
-        </p:txBody>
-      </p:sp>
-      <p:sp>
-        <p:nvSpPr>
-          <p:cNvPr id="35" name="Rectangle 34"/>
+              <a:t>CSV des ouvrages filtrés, registre COSO, cantons prioritaires et feuille de route.</a:t>
+            </a:r>
+          </a:p>
+        </p:txBody>
+      </p:sp>
+      <p:sp>
+        <p:nvSpPr>
+          <p:cNvPr id="24" name="Rectangle 23"/>
+          <p:cNvSpPr/>
+          <p:nvPr/>
+        </p:nvSpPr>
+        <p:spPr>
+          <a:xfrm>
+            <a:off x="7543800" y="5230368"/>
+            <a:ext cx="50800" cy="658368"/>
+          </a:xfrm>
+          <a:prstGeom prst="rect">
+            <a:avLst/>
+          </a:prstGeom>
+          <a:solidFill>
+            <a:srgbClr val="14877D"/>
+          </a:solidFill>
+          <a:ln>
+            <a:noFill/>
+          </a:ln>
+          <a:effectLst/>
+        </p:spPr>
+        <p:style>
+          <a:lnRef idx="1">
+            <a:schemeClr val="accent1"/>
+          </a:lnRef>
+          <a:fillRef idx="3">
+            <a:schemeClr val="accent1"/>
+          </a:fillRef>
+          <a:fontRef idx="minor">
+            <a:schemeClr val="lt1"/>
+          </a:fontRef>
+        </p:style>
+        <p:txBody>
+          <a:bodyPr rtlCol="0" anchor="ctr"/>
+          <a:lstStyle/>
+          <a:p>
+            <a:pPr algn="ctr"/>
+          </a:p>
+        </p:txBody>
+      </p:sp>
+      <p:sp>
+        <p:nvSpPr>
+          <p:cNvPr id="25" name="TextBox 24"/>
+          <p:cNvSpPr txBox="1"/>
+          <p:nvPr/>
+        </p:nvSpPr>
+        <p:spPr>
+          <a:xfrm>
+            <a:off x="7699248" y="5230368"/>
+            <a:ext cx="3657600" cy="228600"/>
+          </a:xfrm>
+          <a:prstGeom prst="rect">
+            <a:avLst/>
+          </a:prstGeom>
+          <a:noFill/>
+        </p:spPr>
+        <p:txBody>
+          <a:bodyPr wrap="square" anchor="t" lIns="50800" rIns="50800" tIns="50800" bIns="50800">
+            <a:spAutoFit/>
+          </a:bodyPr>
+          <a:lstStyle/>
+          <a:p>
+            <a:pPr algn="l"/>
+            <a:r>
+              <a:rPr sz="1150" b="1">
+                <a:solidFill>
+                  <a:srgbClr val="0B4F4A"/>
+                </a:solidFill>
+                <a:latin typeface="Poppins"/>
+              </a:rPr>
+              <a:t>Transparence</a:t>
+            </a:r>
+          </a:p>
+        </p:txBody>
+      </p:sp>
+      <p:sp>
+        <p:nvSpPr>
+          <p:cNvPr id="26" name="TextBox 25"/>
+          <p:cNvSpPr txBox="1"/>
+          <p:nvPr/>
+        </p:nvSpPr>
+        <p:spPr>
+          <a:xfrm>
+            <a:off x="7699248" y="5449824"/>
+            <a:ext cx="3657600" cy="411480"/>
+          </a:xfrm>
+          <a:prstGeom prst="rect">
+            <a:avLst/>
+          </a:prstGeom>
+          <a:noFill/>
+        </p:spPr>
+        <p:txBody>
+          <a:bodyPr wrap="square" anchor="t" lIns="50800" rIns="50800" tIns="50800" bIns="50800">
+            <a:spAutoFit/>
+          </a:bodyPr>
+          <a:lstStyle/>
+          <a:p>
+            <a:pPr algn="l"/>
+            <a:r>
+              <a:rPr sz="1000" b="0">
+                <a:solidFill>
+                  <a:srgbClr val="16302C"/>
+                </a:solidFill>
+                <a:latin typeface="Poppins"/>
+              </a:rPr>
+              <a:t>Le score COSO cible les visites ; il ne remplace pas un relevé fonctionnel de terrain.</a:t>
+            </a:r>
+          </a:p>
+        </p:txBody>
+      </p:sp>
+      <p:sp>
+        <p:nvSpPr>
+          <p:cNvPr id="27" name="Rectangle 26"/>
           <p:cNvSpPr/>
           <p:nvPr/>
         </p:nvSpPr>
@@ -12082,7 +13123,7 @@
       </p:sp>
       <p:sp>
         <p:nvSpPr>
-          <p:cNvPr id="36" name="TextBox 35"/>
+          <p:cNvPr id="28" name="TextBox 27"/>
           <p:cNvSpPr txBox="1"/>
           <p:nvPr/>
         </p:nvSpPr>
@@ -12117,7 +13158,7 @@
       </p:sp>
       <p:sp>
         <p:nvSpPr>
-          <p:cNvPr id="37" name="TextBox 36"/>
+          <p:cNvPr id="29" name="TextBox 28"/>
           <p:cNvSpPr txBox="1"/>
           <p:nvPr/>
         </p:nvSpPr>

</xml_diff>

<commit_message>
Ajouter l auteur au rapport
</commit_message>
<xml_diff>
--- a/reports/rapport.pptx
+++ b/reports/rapport.pptx
@@ -3146,7 +3146,7 @@
         </p:nvSpPr>
         <p:spPr>
           <a:xfrm>
-            <a:off x="0" y="4114800"/>
+            <a:off x="0" y="4315968"/>
             <a:ext cx="12191695" cy="63500"/>
           </a:xfrm>
           <a:prstGeom prst="rect">
@@ -3310,7 +3310,42 @@
       </p:sp>
       <p:sp>
         <p:nvSpPr>
-          <p:cNvPr id="8" name="Rectangle 7"/>
+          <p:cNvPr id="8" name="TextBox 7"/>
+          <p:cNvSpPr txBox="1"/>
+          <p:nvPr/>
+        </p:nvSpPr>
+        <p:spPr>
+          <a:xfrm>
+            <a:off x="731520" y="3913632"/>
+            <a:ext cx="10058400" cy="320040"/>
+          </a:xfrm>
+          <a:prstGeom prst="rect">
+            <a:avLst/>
+          </a:prstGeom>
+          <a:noFill/>
+        </p:spPr>
+        <p:txBody>
+          <a:bodyPr wrap="square" anchor="t" lIns="50800" rIns="50800" tIns="50800" bIns="50800">
+            <a:spAutoFit/>
+          </a:bodyPr>
+          <a:lstStyle/>
+          <a:p>
+            <a:pPr algn="l"/>
+            <a:r>
+              <a:rPr sz="1300" b="1">
+                <a:solidFill>
+                  <a:srgbClr val="FFFFFF"/>
+                </a:solidFill>
+                <a:latin typeface="Poppins"/>
+              </a:rPr>
+              <a:t>Réalisé par : AMAH-TCHOUTCHOUI Elikplim Josué · Août 2026</a:t>
+            </a:r>
+          </a:p>
+        </p:txBody>
+      </p:sp>
+      <p:sp>
+        <p:nvSpPr>
+          <p:cNvPr id="9" name="Rectangle 8"/>
           <p:cNvSpPr/>
           <p:nvPr/>
         </p:nvSpPr>
@@ -3353,7 +3388,7 @@
       </p:sp>
       <p:sp>
         <p:nvSpPr>
-          <p:cNvPr id="9" name="TextBox 8"/>
+          <p:cNvPr id="10" name="TextBox 9"/>
           <p:cNvSpPr txBox="1"/>
           <p:nvPr/>
         </p:nvSpPr>
@@ -3388,7 +3423,7 @@
       </p:sp>
       <p:sp>
         <p:nvSpPr>
-          <p:cNvPr id="10" name="TextBox 9"/>
+          <p:cNvPr id="11" name="TextBox 10"/>
           <p:cNvSpPr txBox="1"/>
           <p:nvPr/>
         </p:nvSpPr>
@@ -3423,7 +3458,7 @@
       </p:sp>
       <p:sp>
         <p:nvSpPr>
-          <p:cNvPr id="11" name="Rectangle 10"/>
+          <p:cNvPr id="12" name="Rectangle 11"/>
           <p:cNvSpPr/>
           <p:nvPr/>
         </p:nvSpPr>
@@ -3466,7 +3501,7 @@
       </p:sp>
       <p:sp>
         <p:nvSpPr>
-          <p:cNvPr id="12" name="TextBox 11"/>
+          <p:cNvPr id="13" name="TextBox 12"/>
           <p:cNvSpPr txBox="1"/>
           <p:nvPr/>
         </p:nvSpPr>
@@ -3501,7 +3536,7 @@
       </p:sp>
       <p:sp>
         <p:nvSpPr>
-          <p:cNvPr id="13" name="TextBox 12"/>
+          <p:cNvPr id="14" name="TextBox 13"/>
           <p:cNvSpPr txBox="1"/>
           <p:nvPr/>
         </p:nvSpPr>
@@ -3536,7 +3571,7 @@
       </p:sp>
       <p:sp>
         <p:nvSpPr>
-          <p:cNvPr id="14" name="Rectangle 13"/>
+          <p:cNvPr id="15" name="Rectangle 14"/>
           <p:cNvSpPr/>
           <p:nvPr/>
         </p:nvSpPr>
@@ -3579,7 +3614,7 @@
       </p:sp>
       <p:sp>
         <p:nvSpPr>
-          <p:cNvPr id="15" name="TextBox 14"/>
+          <p:cNvPr id="16" name="TextBox 15"/>
           <p:cNvSpPr txBox="1"/>
           <p:nvPr/>
         </p:nvSpPr>
@@ -3614,7 +3649,7 @@
       </p:sp>
       <p:sp>
         <p:nvSpPr>
-          <p:cNvPr id="16" name="TextBox 15"/>
+          <p:cNvPr id="17" name="TextBox 16"/>
           <p:cNvSpPr txBox="1"/>
           <p:nvPr/>
         </p:nvSpPr>
@@ -3649,7 +3684,7 @@
       </p:sp>
       <p:sp>
         <p:nvSpPr>
-          <p:cNvPr id="17" name="TextBox 16"/>
+          <p:cNvPr id="18" name="TextBox 17"/>
           <p:cNvSpPr txBox="1"/>
           <p:nvPr/>
         </p:nvSpPr>

</xml_diff>